<commit_message>
Fix XML corruption in day4_day5.pptx (slides 3-4 missing graphicData closing tag)
</commit_message>
<xml_diff>
--- a/tencent_cjob_day4_day5.pptx
+++ b/tencent_cjob_day4_day5.pptx
@@ -6398,145 +6398,2033 @@
 </p:sld>
 </file>
 
-<file path=ppt/slides/slide3.xml><?xml version="1.0" encoding="UTF-8" standalone="yes"?>
+<file path=ppt/slides/slide3.xml><?xml version="1.0" encoding="utf-8"?>
 <p:sld xmlns:a="http://schemas.openxmlformats.org/drawingml/2006/main" xmlns:p="http://schemas.openxmlformats.org/presentationml/2006/main" xmlns:r="http://schemas.openxmlformats.org/officeDocument/2006/relationships">
-<p:cSld>
-<p:bg><p:bgPr><a:solidFill><a:srgbClr val="1A1A2E"/></a:solidFill><a:effectLst/></p:bgPr></p:bg>
-<p:spTree>
-<p:nvGrpSpPr><p:cNvPr id="1" name=""/><p:cNvGrpSpPr/><p:nvPr/></p:nvGrpSpPr>
-<p:grpSpPr/>
-<p:sp><p:nvSpPr><p:cNvPr id="2" name="Header Bar"/><p:cNvSpPr/><p:nvPr/></p:nvSpPr>
-<p:spPr><a:xfrm><a:off x="0" y="0"/><a:ext cx="12188952" cy="1097280"/></a:xfrm><a:prstGeom prst="rect"><a:avLst/></a:prstGeom><a:solidFill><a:srgbClr val="004A8A"/></a:solidFill><a:ln><a:noFill/></a:ln></p:spPr>
-<p:txBody><a:bodyPr rtlCol="0" anchor="ctr"/><a:lstStyle/><a:p><a:pPr algn="ctr"/></a:p></p:txBody></p:sp>
-<p:sp><p:nvSpPr><p:cNvPr id="3" name="Title"/><p:cNvSpPr txBox="1"/><p:nvPr/></p:nvSpPr>
-<p:spPr><a:xfrm><a:off x="274320" y="91440"/><a:ext cx="10972800" cy="731520"/></a:xfrm><a:prstGeom prst="rect"><a:avLst/></a:prstGeom><a:noFill/></p:spPr>
-<p:txBody><a:bodyPr wrap="square"><a:spAutoFit/></a:bodyPr><a:lstStyle/><a:p><a:pPr algn="ctr"/><a:r><a:rPr sz="2800" b="1" i="0"><a:solidFill><a:srgbClr val="FFFFFF"/></a:solidFill></a:rPr><a:t>腾讯AI战略研究 — C Job Day 4 分析师观点 &amp; 竞争格局</a:t></a:r></a:p></p:txBody></p:sp>
-<p:sp><p:nvSpPr><p:cNvPr id="4" name="Subtitle"/><p:cNvSpPr txBox="1"/><p:nvPr/></p:nvSpPr>
-<p:spPr><a:xfrm><a:off x="274320" y="1188720"/><a:ext cx="10972800" cy="365760"/></a:xfrm><a:prstGeom prst="rect"><a:avLst/></a:prstGeom><a:noFill/></p:spPr>
-<p:txBody><a:bodyPr wrap="square"><a:spAutoFit/></a:bodyPr><a:lstStyle/><a:p><a:pPr algn="ctr"/><a:r><a:rPr sz="1400" b="0" i="1"><a:solidFill><a:srgbClr val="D4AF37"/></a:solidFill></a:rPr><a:t>分析师观点汇总 · 竞争格局对比 · 估值支撑</a:t></a:r></a:p></p:txBody></p:sp>
-<p:sp><p:nvSpPr><p:cNvPr id="5" name="SectionBox1"/><p:cNvSpPr/><p:nvPr/></p:nvSpPr>
-<p:spPr><a:xfrm><a:off x="274320" y="1737360"/><a:ext cx="5303520" cy="457200"/></a:xfrm><a:prstGeom prst="rect"><a:avLst/></a:prstGeom><a:solidFill><a:srgbClr val="004A8A"/></a:solidFill><a:ln><a:noFill/></a:ln></p:spPr>
-<p:txBody><a:bodyPr rtlCol="0" anchor="ctr"/><a:lstStyle/><a:p><a:pPr algn="ctr"/></a:p></p:txBody></p:sp>
-<p:sp><p:nvSpPr><p:cNvPr id="6" name="SectionTitle1"/><p:cNvSpPr txBox="1"/><p:nvPr/></p:nvSpPr>
-<p:spPr><a:xfrm><a:off x="365760" y="1783080"/><a:ext cx="5120640" cy="365760"/></a:xfrm><a:prstGeom prst="rect"><a:avLst/></a:prstGeom><a:noFill/></p:spPr>
-<p:txBody><a:bodyPr wrap="square"><a:spAutoFit/></a:bodyPr><a:lstStyle/><a:p><a:pPr algn="l"/><a:r><a:rPr sz="1400" b="1" i="0"><a:solidFill><a:srgbClr val="FFFFFF"/></a:solidFill></a:rPr><a:t>📋 分析师观点汇总</a:t></a:r></a:p></p:txBody></p:sp>
-<p:graphicFrame><p:nvGraphicFramePr><p:cNvPr id="7" name="AnalystTable"/><p:cNvGraphicFramePr><a:graphicFrameLocks noGrp="1"/></p:cNvGraphicFramePr><p:nvPr/></p:nvGraphicFramePr>
-<p:xfrm><a:off x="274320" y="2286000"/><a:ext cx="5303520" cy="2286000"/></p:xfrm>
-<a:graphic><a:graphicData uri="http://schemas.openxmlformats.org/drawingml/2006/table"><a:tbl><a:tblPr firstRow="1" bandRow="1"><a:tableStyleId>{5C22544A-7EE6-4342-B048-85BDC9FD1C3A}</a:tableStyleId></a:tblPr>
-<a:tblGrid><a:gridCol w="1800000"/><a:gridCol w="3503520"/></a:tblGrid>
-<a:tr h="320000"><a:tc><a:txBody><a:bodyPr/><a:lstStyle/><a:p><a:pPr algn="ctr"><a:defRPr sz="1100" b="1"><a:solidFill><a:srgbClr val="FFFFFF"/></a:solidFill></a:defRPr></a:pPr><a:r><a:t>维度</a:t></a:r></a:p></a:txBody><a:tcPr><a:solidFill><a:srgbClr val="004A8A"/></a:solidFill></a:tcPr></a:tc>
-<a:tc><a:txBody><a:bodyPr/><a:lstStyle/><a:p><a:pPr algn="ctr"><a:defRPr sz="1100" b="1"><a:solidFill><a:srgbClr val="FFFFFF"/></a:solidFill></a:defRPr></a:pPr><a:r><a:t>内容</a:t></a:r></a:p></a:txBody><a:tcPr><a:solidFill><a:srgbClr val="004A8A"/></a:solidFill></a:tcPr></a:tc></a:tr>
-<a:tr h="320000"><a:tc><a:txBody><a:bodyPr/><a:lstStyle/><a:p><a:pPr algn="l"><a:defRPr sz="1100"><a:solidFill><a:srgbClr val="FFFFFF"/></a:solidFill></a:defRPr></a:pPr><a:r><a:t>估值依据</a:t></a:r></a:p></a:txBody><a:tcPr/></a:tc><a:tc><a:txBody><a:bodyPr/><a:lstStyle/><a:p><a:pPr algn="l"><a:defRPr sz="1100"><a:solidFill><a:srgbClr val="FFFFFF"/></a:solidFill></a:defRPr></a:pPr><a:r><a:t>439港元 / PE12倍，低于历史中枢18-20倍</a:t></a:r></a:p></a:txBody><a:tcPr/></a:tc></a:tr>
-<a:tr h="320000"><a:tc><a:txBody><a:bodyPr/><a:lstStyle/><a:p><a:pPr algn="l"><a:defRPr sz="1100"><a:solidFill><a:srgbClr val="FFFFFF"/></a:solidFill></a:defRPr></a:pPr><a:r><a:t>目标价区间</a:t></a:r></a:p></a:txBody><a:tcPr/></a:tc><a:tc><a:txBody><a:bodyPr/><a:lstStyle/><a:p><a:pPr algn="l"><a:defRPr sz="1100"><a:solidFill><a:srgbClr val="FFFFFF"/></a:solidFill></a:defRPr></a:pPr><a:r><a:t>HKD 470-520（潜在涨幅 +8%~+18%）</a:t></a:r></a:p></a:txBody><a:tcPr/></a:tc></a:tr>
-<a:tr h="320000"><a:tc><a:txBody><a:bodyPr/><a:lstStyle/><a:p><a:pPr algn="l"><a:defRPr sz="1100"><a:solidFill><a:srgbClr val="FFFFFF"/></a:solidFill></a:defRPr></a:pPr><a:r><a:t>情景分析</a:t></a:r></a:p></a:txBody><a:tcPr/></a:tc><a:tc><a:txBody><a:bodyPr/><a:lstStyle/><a:p><a:pPr algn="l"><a:defRPr sz="1100"><a:solidFill><a:srgbClr val="FFFFFF"/></a:solidFill></a:defRPr></a:pPr><a:r><a:t>Bull 706港元(+61%) / Base 545港元(+24%) / Bear 366港元(-17%)</a:t></a:r></a:p></a:txBody><a:tcPr/></a:tc></a:tr>
-<a:tr h="320000"><a:tc><a:txBody><a:bodyPr/><a:lstStyle/><a:p><a:pPr algn="l"><a:defRPr sz="1100"><a:solidFill><a:srgbClr val="FFFFFF"/></a:solidFill></a:defRPr></a:pPr><a:r><a:t>投资建议</a:t></a:r></a:p></a:txBody><a:tcPr/></a:tc><a:tc><a:txBody><a:bodyPr/><a:lstStyle/><a:p><a:pPr algn="l"><a:defRPr sz="1100"><a:solidFill><a:srgbClr val="D4AF37"/></a:solidFill></a:defRPr></a:pPr><a:r><a:t>中期谨慎买入，长期强烈买入</a:t></a:r></a:p></a:txBody><a:tcPr/></a:tc></a:tr>
-<a:tr h="320000"><a:tc><a:txBody><a:bodyPr/><a:lstStyle/><a:p><a:pPr algn="l"><a:defRPr sz="1100"><a:solidFill><a:srgbClr val="FFFFFF"/></a:solidFill></a:defRPr></a:pPr><a:r><a:t>催化剂</a:t></a:r></a:p></a:txBody><a:tcPr/></a:tc><a:tc><a:txBody><a:bodyPr/><a:lstStyle/><a:p><a:pPr algn="l"><a:defRPr sz="1100"><a:solidFill><a:srgbClr val="FFFFFF"/></a:solidFill></a:defRPr></a:pPr><a:r><a:t>微信Agent爆发 / Hy3落地规模 / AI变现验证</a:t></a:r></a:p></a:txBody><a:tcPr/></a:tc></a:tr>
-</a:tbl></a:graphic></p:graphicFrame>
-<p:sp><p:nvSpPr><p:cNvPr id="8" name="SectionBox2"/><p:cNvSpPr/><p:nvPr/></p:nvSpPr>
-<p:spPr><a:xfrm><a:off x="5944560" y="1737360"/><a:ext cx="5891040" cy="457200"/></a:xfrm><a:prstGeom prst="rect"><a:avLst/></a:prstGeom><a:solidFill><a:srgbClr val="8B0000"/></a:solidFill><a:ln><a:noFill/></a:ln></p:spPr>
-<p:txBody><a:bodyPr rtlCol="0" anchor="ctr"/><a:lstStyle/><a:p><a:pPr algn="ctr"/></a:p></p:txBody></p:sp>
-<p:sp><p:nvSpPr><p:cNvPr id="9" name="SectionTitle2"/><p:cNvSpPr txBox="1"/><p:nvPr/></p:nvSpPr>
-<p:spPr><a:xfrm><a:off x="6034560" y="1783080"/><a:ext cx="5708640" cy="365760"/></a:xfrm><a:prstGeom prst="rect"><a:avLst/></a:prstGeom><a:noFill/></p:spPr>
-<p:txBody><a:bodyPr wrap="square"><a:spAutoFit/></a:bodyPr><a:lstStyle/><a:p><a:pPr algn="l"/><a:r><a:rPr sz="1400" b="1" i="0"><a:solidFill><a:srgbClr val="FFFFFF"/></a:solidFill></a:rPr><a:t>⚔️ 竞争格局对比</a:t></a:r></a:p></p:txBody></p:sp>
-<p:graphicFrame><p:nvGraphicFramePr><p:cNvPr id="10" name="CompTable"/><p:cNvGraphicFramePr><a:graphicFrameLocks noGrp="1"/></p:cNvGraphicFramePr><p:nvPr/></p:nvGraphicFramePr>
-<p:xfrm><a:off x="5944560" y="2286000"/><a:ext cx="5891040" cy="2286000"/></p:xfrm>
-<a:graphic><a:graphicData uri="http://schemas.openxmlformats.org/drawingml/2006/table"><a:tbl><a:tblPr firstRow="1" bandRow="1"><a:tableStyleId>{5C22544A-7EE6-4342-B048-85BDC9FD1C3A}</a:tableStyleId></a:tblPr>
-<a:tblGrid><a:gridCol w="1500000"/><a:gridCol w="1500000"/><a:gridCol w="2891040"/></a:tblGrid>
-<a:tr h="320000"><a:tc><a:txBody><a:bodyPr/><a:lstStyle/><a:p><a:pPr algn="ctr"><a:defRPr sz="1100" b="1"><a:solidFill><a:srgbClr val="FFFFFF"/></a:solidFill></a:defRPr></a:pPr><a:r><a:t>维度</a:t></a:r></a:p></a:txBody><a:tcPr><a:solidFill><a:srgbClr val="8B0000"/></a:solidFill></a:tcPr></a:tc>
-<a:tc><a:txBody><a:bodyPr/><a:lstStyle/><a:p><a:pPr algn="ctr"><a:defRPr sz="1100" b="1"><a:solidFill><a:srgbClr val="FFFFFF"/></a:solidFill></a:defRPr></a:pPr><a:r><a:t>腾讯</a:t></a:r></a:p></a:txBody><a:tcPr><a:solidFill><a:srgbClr val="8B0000"/></a:solidFill></a:tcPr></a:tc>
-<a:tc><a:txBody><a:bodyPr/><a:lstStyle/><a:p><a:pPr algn="ctr"><a:defRPr sz="1100" b="1"><a:solidFill><a:srgbClr val="FFFFFF"/></a:solidFill></a:defRPr></a:pPr><a:r><a:t>Meta</a:t></a:r></a:p></a:txBody><a:tcPr><a:solidFill><a:srgbClr val="8B0000"/></a:solidFill></a:tcPr></a:tc></a:tr>
-<a:tr h="320000"><a:tc><a:txBody><a:bodyPr/><a:lstStyle/><a:p><a:pPr algn="l"><a:defRPr sz="1100"><a:solidFill><a:srgbClr val="FFFFFF"/></a:solidFill></a:defRPr></a:pPr><a:r><a:t>AI策略</a:t></a:r></a:p></a:txBody><a:tcPr/></a:tc><a:tc><a:txBody><a:bodyPr/><a:lstStyle/><a:p><a:pPr algn="l"><a:defRPr sz="1100"><a:solidFill><a:srgbClr val="FFFFFF"/></a:solidFill></a:defRPr></a:pPr><a:r><a:t>渐进验证，真实场景优先</a:t></a:r></a:p></a:txBody><a:tcPr/></a:tc><a:tc><a:txBody><a:bodyPr/><a:lstStyle/><a:p><a:pPr algn="l"><a:defRPr sz="1100"><a:solidFill><a:srgbClr val="FFFFFF"/></a:solidFill></a:defRPr></a:pPr><a:r><a:t>All-in 各种热点</a:t></a:r></a:p></a:txBody><a:tcPr/></a:tc></a:tr>
-<a:tr h="320000"><a:tc><a:txBody><a:bodyPr/><a:lstStyle/><a:p><a:pPr algn="l"><a:defRPr sz="1100"><a:solidFill><a:srgbClr val="FFFFFF"/></a:solidFill></a:defRPr></a:pPr><a:r><a:t>速度</a:t></a:r></a:p></a:txBody><a:tcPr/></a:tc><a:tc><a:txBody><a:bodyPr/><a:lstStyle/><a:p><a:pPr algn="ctr"><a:defRPr sz="1100"><a:solidFill><a:srgbClr val="00FF00"/></a:solidFill></a:defRPr></a:pPr><a:r><a:t>慢</a:t></a:r></a:p></a:txBody><a:tcPr/></a:tc><a:tc><a:txBody><a:bodyPr/><a:lstStyle/><a:p><a:pPr algn="ctr"><a:defRPr sz="1100"><a:solidFill><a:srgbClr val="FF6666"/></a:solidFill></a:defRPr></a:pPr><a:r><a:t>快</a:t></a:r></a:p></a:txBody><a:tcPr/></a:tc></a:tr>
-<a:tr h="320000"><a:tc><a:txBody><a:bodyPr/><a:lstStyle/><a:p><a:pPr algn="l"><a:defRPr sz="1100"><a:solidFill><a:srgbClr val="FFFFFF"/></a:solidFill></a:defRPr></a:pPr><a:r><a:t>风险偏好</a:t></a:r></a:p></a:txBody><a:tcPr/></a:tc><a:tc><a:txBody><a:bodyPr/><a:lstStyle/><a:p><a:pPr algn="l"><a:defRPr sz="1100"><a:solidFill><a:srgbClr val="FFFFFF"/></a:solidFill></a:defRPr></a:pPr><a:r><a:t>低（不成熟方案不上线）</a:t></a:r></a:p></a:txBody><a:tcPr/></a:tc><a:tc><a:txBody><a:bodyPr/><a:lstStyle/><a:p><a:pPr algn="l"><a:defRPr sz="1100"><a:solidFill><a:srgbClr val="FFFFFF"/></a:solidFill></a:defRPr></a:pPr><a:r><a:t>高（追逐热点踏空风险）</a:t></a:r></a:p></a:txBody><a:tcPr/></a:tc></a:tr>
-<a:tr h="320000"><a:tc><a:txBody><a:bodyPr/><a:lstStyle/><a:p><a:pPr algn="l"><a:defRPr sz="1100"><a:solidFill><a:srgbClr val="FFFFFF"/></a:solidFill></a:defRPr></a:pPr><a:r><a:t>护城河</a:t></a:r></a:p></a:txBody><a:tcPr/></a:tc><a:tc><a:txBody><a:bodyPr/><a:lstStyle/><a:p><a:pPr algn="l"><a:defRPr sz="1100"><a:solidFill><a:srgbClr val="00FF00"/></a:solidFill></a:defRPr></a:pPr><a:r><a:t>验证体系一旦建立极难复制</a:t></a:r></a:p></a:txBody><a:tcPr/></a:tc><a:tc><a:txBody><a:bodyPr/><a:lstStyle/><a:p><a:pPr algn="l"><a:defRPr sz="1100"><a:solidFill><a:srgbClr val="FF6666"/></a:solidFill></a:defRPr></a:pPr><a:r><a:t>热点分散无护城河</a:t></a:r></a:p></a:txBody><a:tcPr/></a:tc></a:tr>
-<a:tr h="320000"><a:tc><a:txBody><a:bodyPr/><a:lstStyle/><a:p><a:pPr algn="l"><a:defRPr sz="1100"><a:solidFill><a:srgbClr val="FFFFFF"/></a:solidFill></a:defRPr></a:pPr><a:r><a:t>Agent爆发概率(2027)</a:t></a:r></a:p></a:txBody><a:tcPr/></a:tc><a:tc><a:txBody><a:bodyPr/><a:lstStyle/><a:p><a:pPr algn="ctr"><a:defRPr sz="1100" b="1"><a:solidFill><a:srgbClr val="00FF00"/></a:solidFill></a:defRPr></a:pPr><a:r><a:t>60-70%</a:t></a:r></a:p></a:txBody><a:tcPr/></a:tc><a:tc><a:txBody><a:bodyPr/><a:lstStyle/><a:p><a:pPr algn="ctr"><a:defRPr sz="1100"><a:solidFill><a:srgbClr val="AAAAAA"/></a:solidFill></a:defRPr></a:pPr><a:r><a:t>—</a:t></a:r></a:p></a:txBody><a:tcPr/></a:tc></a:tr>
-</a:tbl></a:graphic></p:graphicFrame>
-<p:sp><p:nvSpPr><p:cNvPr id="11" name="FooterBox"/><p:cNvSpPr/><p:nvPr/></p:nvSpPr>
-<p:spPr><a:xfrm><a:off x="0" y="6400000"/><a:ext cx="12188952" cy="457600"/></a:xfrm><a:prstGeom prst="rect"><a:avLst/></a:prstGeom><a:solidFill><a:srgbClr val="004A8A"/></a:solidFill><a:ln><a:noFill/></a:ln></p:spPr>
-<p:txBody><a:bodyPr rtlCol="0" anchor="ctr"/><a:lstStyle/><a:p><a:pPr algn="ctr"/><a:r><a:rPr sz="1000"><a:solidFill><a:srgbClr val="AAAAAA"/></a:solidFill></a:rPr><a:t>数据来源：腾讯官方财报 / 分析师估算 | C Job Day 4</a:t></a:r></a:p></p:txBody></p:sp>
-</p:spTree>
-</p:cSld>
-<p:clrMapOvr><a:masterClrMapping/></p:clrMapOvr>
+  <p:cSld>
+    <p:bg>
+      <p:bgPr>
+        <a:solidFill>
+          <a:srgbClr val="1A1A2E"/>
+        </a:solidFill>
+        <a:effectLst/>
+      </p:bgPr>
+    </p:bg>
+    <p:spTree>
+      <p:nvGrpSpPr>
+        <p:cNvPr id="1" name=""/>
+        <p:cNvGrpSpPr/>
+        <p:nvPr/>
+      </p:nvGrpSpPr>
+      <p:grpSpPr/>
+      <p:sp>
+        <p:nvSpPr>
+          <p:cNvPr id="2" name="Header Bar"/>
+          <p:cNvSpPr/>
+          <p:nvPr/>
+        </p:nvSpPr>
+        <p:spPr>
+          <a:xfrm>
+            <a:off x="0" y="0"/>
+            <a:ext cx="12188952" cy="1097280"/>
+          </a:xfrm>
+          <a:prstGeom prst="rect">
+            <a:avLst/>
+          </a:prstGeom>
+          <a:solidFill>
+            <a:srgbClr val="004A8A"/>
+          </a:solidFill>
+          <a:ln>
+            <a:noFill/>
+          </a:ln>
+        </p:spPr>
+        <p:txBody>
+          <a:bodyPr rtlCol="0" anchor="ctr"/>
+          <a:lstStyle/>
+          <a:p>
+            <a:pPr algn="ctr"/>
+          </a:p>
+        </p:txBody>
+      </p:sp>
+      <p:sp>
+        <p:nvSpPr>
+          <p:cNvPr id="3" name="Title"/>
+          <p:cNvSpPr txBox="1"/>
+          <p:nvPr/>
+        </p:nvSpPr>
+        <p:spPr>
+          <a:xfrm>
+            <a:off x="274320" y="91440"/>
+            <a:ext cx="10972800" cy="731520"/>
+          </a:xfrm>
+          <a:prstGeom prst="rect">
+            <a:avLst/>
+          </a:prstGeom>
+          <a:noFill/>
+        </p:spPr>
+        <p:txBody>
+          <a:bodyPr wrap="square">
+            <a:spAutoFit/>
+          </a:bodyPr>
+          <a:lstStyle/>
+          <a:p>
+            <a:pPr algn="ctr"/>
+            <a:r>
+              <a:rPr sz="2800" b="1" i="0">
+                <a:solidFill>
+                  <a:srgbClr val="FFFFFF"/>
+                </a:solidFill>
+              </a:rPr>
+              <a:t>腾讯AI战略研究 — C Job Day 4 分析师观点 &amp; 竞争格局</a:t>
+            </a:r>
+          </a:p>
+        </p:txBody>
+      </p:sp>
+      <p:sp>
+        <p:nvSpPr>
+          <p:cNvPr id="4" name="Subtitle"/>
+          <p:cNvSpPr txBox="1"/>
+          <p:nvPr/>
+        </p:nvSpPr>
+        <p:spPr>
+          <a:xfrm>
+            <a:off x="274320" y="1188720"/>
+            <a:ext cx="10972800" cy="365760"/>
+          </a:xfrm>
+          <a:prstGeom prst="rect">
+            <a:avLst/>
+          </a:prstGeom>
+          <a:noFill/>
+        </p:spPr>
+        <p:txBody>
+          <a:bodyPr wrap="square">
+            <a:spAutoFit/>
+          </a:bodyPr>
+          <a:lstStyle/>
+          <a:p>
+            <a:pPr algn="ctr"/>
+            <a:r>
+              <a:rPr sz="1400" b="0" i="1">
+                <a:solidFill>
+                  <a:srgbClr val="D4AF37"/>
+                </a:solidFill>
+              </a:rPr>
+              <a:t>分析师观点汇总 · 竞争格局对比 · 估值支撑</a:t>
+            </a:r>
+          </a:p>
+        </p:txBody>
+      </p:sp>
+      <p:sp>
+        <p:nvSpPr>
+          <p:cNvPr id="5" name="SectionBox1"/>
+          <p:cNvSpPr/>
+          <p:nvPr/>
+        </p:nvSpPr>
+        <p:spPr>
+          <a:xfrm>
+            <a:off x="274320" y="1737360"/>
+            <a:ext cx="5303520" cy="457200"/>
+          </a:xfrm>
+          <a:prstGeom prst="rect">
+            <a:avLst/>
+          </a:prstGeom>
+          <a:solidFill>
+            <a:srgbClr val="004A8A"/>
+          </a:solidFill>
+          <a:ln>
+            <a:noFill/>
+          </a:ln>
+        </p:spPr>
+        <p:txBody>
+          <a:bodyPr rtlCol="0" anchor="ctr"/>
+          <a:lstStyle/>
+          <a:p>
+            <a:pPr algn="ctr"/>
+          </a:p>
+        </p:txBody>
+      </p:sp>
+      <p:sp>
+        <p:nvSpPr>
+          <p:cNvPr id="6" name="SectionTitle1"/>
+          <p:cNvSpPr txBox="1"/>
+          <p:nvPr/>
+        </p:nvSpPr>
+        <p:spPr>
+          <a:xfrm>
+            <a:off x="365760" y="1783080"/>
+            <a:ext cx="5120640" cy="365760"/>
+          </a:xfrm>
+          <a:prstGeom prst="rect">
+            <a:avLst/>
+          </a:prstGeom>
+          <a:noFill/>
+        </p:spPr>
+        <p:txBody>
+          <a:bodyPr wrap="square">
+            <a:spAutoFit/>
+          </a:bodyPr>
+          <a:lstStyle/>
+          <a:p>
+            <a:pPr algn="l"/>
+            <a:r>
+              <a:rPr sz="1400" b="1" i="0">
+                <a:solidFill>
+                  <a:srgbClr val="FFFFFF"/>
+                </a:solidFill>
+              </a:rPr>
+              <a:t>📋 分析师观点汇总</a:t>
+            </a:r>
+          </a:p>
+        </p:txBody>
+      </p:sp>
+      <p:graphicFrame>
+        <p:nvGraphicFramePr>
+          <p:cNvPr id="7" name="AnalystTable"/>
+          <p:cNvGraphicFramePr>
+            <a:graphicFrameLocks noGrp="1"/>
+          </p:cNvGraphicFramePr>
+          <p:nvPr/>
+        </p:nvGraphicFramePr>
+        <p:xfrm>
+          <a:off x="274320" y="2286000"/>
+          <a:ext cx="5303520" cy="2286000"/>
+        </p:xfrm>
+        <a:graphic>
+          <a:graphicData uri="http://schemas.openxmlformats.org/drawingml/2006/table">
+            <a:tbl>
+              <a:tblPr firstRow="1" bandRow="1">
+                <a:tableStyleId>{5C22544A-7EE6-4342-B048-85BDC9FD1C3A}</a:tableStyleId>
+              </a:tblPr>
+              <a:tblGrid>
+                <a:gridCol w="1800000"/>
+                <a:gridCol w="3503520"/>
+              </a:tblGrid>
+              <a:tr h="320000">
+                <a:tc>
+                  <a:txBody>
+                    <a:bodyPr/>
+                    <a:lstStyle/>
+                    <a:p>
+                      <a:pPr algn="ctr">
+                        <a:defRPr sz="1100" b="1">
+                          <a:solidFill>
+                            <a:srgbClr val="FFFFFF"/>
+                          </a:solidFill>
+                        </a:defRPr>
+                      </a:pPr>
+                      <a:r>
+                        <a:t>维度</a:t>
+                      </a:r>
+                    </a:p>
+                  </a:txBody>
+                  <a:tcPr>
+                    <a:solidFill>
+                      <a:srgbClr val="004A8A"/>
+                    </a:solidFill>
+                  </a:tcPr>
+                </a:tc>
+                <a:tc>
+                  <a:txBody>
+                    <a:bodyPr/>
+                    <a:lstStyle/>
+                    <a:p>
+                      <a:pPr algn="ctr">
+                        <a:defRPr sz="1100" b="1">
+                          <a:solidFill>
+                            <a:srgbClr val="FFFFFF"/>
+                          </a:solidFill>
+                        </a:defRPr>
+                      </a:pPr>
+                      <a:r>
+                        <a:t>内容</a:t>
+                      </a:r>
+                    </a:p>
+                  </a:txBody>
+                  <a:tcPr>
+                    <a:solidFill>
+                      <a:srgbClr val="004A8A"/>
+                    </a:solidFill>
+                  </a:tcPr>
+                </a:tc>
+              </a:tr>
+              <a:tr h="320000">
+                <a:tc>
+                  <a:txBody>
+                    <a:bodyPr/>
+                    <a:lstStyle/>
+                    <a:p>
+                      <a:pPr algn="l">
+                        <a:defRPr sz="1100">
+                          <a:solidFill>
+                            <a:srgbClr val="FFFFFF"/>
+                          </a:solidFill>
+                        </a:defRPr>
+                      </a:pPr>
+                      <a:r>
+                        <a:t>估值依据</a:t>
+                      </a:r>
+                    </a:p>
+                  </a:txBody>
+                  <a:tcPr/>
+                </a:tc>
+                <a:tc>
+                  <a:txBody>
+                    <a:bodyPr/>
+                    <a:lstStyle/>
+                    <a:p>
+                      <a:pPr algn="l">
+                        <a:defRPr sz="1100">
+                          <a:solidFill>
+                            <a:srgbClr val="FFFFFF"/>
+                          </a:solidFill>
+                        </a:defRPr>
+                      </a:pPr>
+                      <a:r>
+                        <a:t>439港元 / PE12倍，低于历史中枢18-20倍</a:t>
+                      </a:r>
+                    </a:p>
+                  </a:txBody>
+                  <a:tcPr/>
+                </a:tc>
+              </a:tr>
+              <a:tr h="320000">
+                <a:tc>
+                  <a:txBody>
+                    <a:bodyPr/>
+                    <a:lstStyle/>
+                    <a:p>
+                      <a:pPr algn="l">
+                        <a:defRPr sz="1100">
+                          <a:solidFill>
+                            <a:srgbClr val="FFFFFF"/>
+                          </a:solidFill>
+                        </a:defRPr>
+                      </a:pPr>
+                      <a:r>
+                        <a:t>目标价区间</a:t>
+                      </a:r>
+                    </a:p>
+                  </a:txBody>
+                  <a:tcPr/>
+                </a:tc>
+                <a:tc>
+                  <a:txBody>
+                    <a:bodyPr/>
+                    <a:lstStyle/>
+                    <a:p>
+                      <a:pPr algn="l">
+                        <a:defRPr sz="1100">
+                          <a:solidFill>
+                            <a:srgbClr val="FFFFFF"/>
+                          </a:solidFill>
+                        </a:defRPr>
+                      </a:pPr>
+                      <a:r>
+                        <a:t>HKD 470-520（潜在涨幅 +8%~+18%）</a:t>
+                      </a:r>
+                    </a:p>
+                  </a:txBody>
+                  <a:tcPr/>
+                </a:tc>
+              </a:tr>
+              <a:tr h="320000">
+                <a:tc>
+                  <a:txBody>
+                    <a:bodyPr/>
+                    <a:lstStyle/>
+                    <a:p>
+                      <a:pPr algn="l">
+                        <a:defRPr sz="1100">
+                          <a:solidFill>
+                            <a:srgbClr val="FFFFFF"/>
+                          </a:solidFill>
+                        </a:defRPr>
+                      </a:pPr>
+                      <a:r>
+                        <a:t>情景分析</a:t>
+                      </a:r>
+                    </a:p>
+                  </a:txBody>
+                  <a:tcPr/>
+                </a:tc>
+                <a:tc>
+                  <a:txBody>
+                    <a:bodyPr/>
+                    <a:lstStyle/>
+                    <a:p>
+                      <a:pPr algn="l">
+                        <a:defRPr sz="1100">
+                          <a:solidFill>
+                            <a:srgbClr val="FFFFFF"/>
+                          </a:solidFill>
+                        </a:defRPr>
+                      </a:pPr>
+                      <a:r>
+                        <a:t>Bull 706港元(+61%) / Base 545港元(+24%) / Bear 366港元(-17%)</a:t>
+                      </a:r>
+                    </a:p>
+                  </a:txBody>
+                  <a:tcPr/>
+                </a:tc>
+              </a:tr>
+              <a:tr h="320000">
+                <a:tc>
+                  <a:txBody>
+                    <a:bodyPr/>
+                    <a:lstStyle/>
+                    <a:p>
+                      <a:pPr algn="l">
+                        <a:defRPr sz="1100">
+                          <a:solidFill>
+                            <a:srgbClr val="FFFFFF"/>
+                          </a:solidFill>
+                        </a:defRPr>
+                      </a:pPr>
+                      <a:r>
+                        <a:t>投资建议</a:t>
+                      </a:r>
+                    </a:p>
+                  </a:txBody>
+                  <a:tcPr/>
+                </a:tc>
+                <a:tc>
+                  <a:txBody>
+                    <a:bodyPr/>
+                    <a:lstStyle/>
+                    <a:p>
+                      <a:pPr algn="l">
+                        <a:defRPr sz="1100">
+                          <a:solidFill>
+                            <a:srgbClr val="D4AF37"/>
+                          </a:solidFill>
+                        </a:defRPr>
+                      </a:pPr>
+                      <a:r>
+                        <a:t>中期谨慎买入，长期强烈买入</a:t>
+                      </a:r>
+                    </a:p>
+                  </a:txBody>
+                  <a:tcPr/>
+                </a:tc>
+              </a:tr>
+              <a:tr h="320000">
+                <a:tc>
+                  <a:txBody>
+                    <a:bodyPr/>
+                    <a:lstStyle/>
+                    <a:p>
+                      <a:pPr algn="l">
+                        <a:defRPr sz="1100">
+                          <a:solidFill>
+                            <a:srgbClr val="FFFFFF"/>
+                          </a:solidFill>
+                        </a:defRPr>
+                      </a:pPr>
+                      <a:r>
+                        <a:t>催化剂</a:t>
+                      </a:r>
+                    </a:p>
+                  </a:txBody>
+                  <a:tcPr/>
+                </a:tc>
+                <a:tc>
+                  <a:txBody>
+                    <a:bodyPr/>
+                    <a:lstStyle/>
+                    <a:p>
+                      <a:pPr algn="l">
+                        <a:defRPr sz="1100">
+                          <a:solidFill>
+                            <a:srgbClr val="FFFFFF"/>
+                          </a:solidFill>
+                        </a:defRPr>
+                      </a:pPr>
+                      <a:r>
+                        <a:t>微信Agent爆发 / Hy3落地规模 / AI变现验证</a:t>
+                      </a:r>
+                    </a:p>
+                  </a:txBody>
+                  <a:tcPr/>
+                </a:tc>
+              </a:tr>
+            </a:tbl>
+          </a:graphicData>
+        </a:graphic>
+      </p:graphicFrame>
+      <p:sp>
+        <p:nvSpPr>
+          <p:cNvPr id="8" name="SectionBox2"/>
+          <p:cNvSpPr/>
+          <p:nvPr/>
+        </p:nvSpPr>
+        <p:spPr>
+          <a:xfrm>
+            <a:off x="5944560" y="1737360"/>
+            <a:ext cx="5891040" cy="457200"/>
+          </a:xfrm>
+          <a:prstGeom prst="rect">
+            <a:avLst/>
+          </a:prstGeom>
+          <a:solidFill>
+            <a:srgbClr val="8B0000"/>
+          </a:solidFill>
+          <a:ln>
+            <a:noFill/>
+          </a:ln>
+        </p:spPr>
+        <p:txBody>
+          <a:bodyPr rtlCol="0" anchor="ctr"/>
+          <a:lstStyle/>
+          <a:p>
+            <a:pPr algn="ctr"/>
+          </a:p>
+        </p:txBody>
+      </p:sp>
+      <p:sp>
+        <p:nvSpPr>
+          <p:cNvPr id="9" name="SectionTitle2"/>
+          <p:cNvSpPr txBox="1"/>
+          <p:nvPr/>
+        </p:nvSpPr>
+        <p:spPr>
+          <a:xfrm>
+            <a:off x="6034560" y="1783080"/>
+            <a:ext cx="5708640" cy="365760"/>
+          </a:xfrm>
+          <a:prstGeom prst="rect">
+            <a:avLst/>
+          </a:prstGeom>
+          <a:noFill/>
+        </p:spPr>
+        <p:txBody>
+          <a:bodyPr wrap="square">
+            <a:spAutoFit/>
+          </a:bodyPr>
+          <a:lstStyle/>
+          <a:p>
+            <a:pPr algn="l"/>
+            <a:r>
+              <a:rPr sz="1400" b="1" i="0">
+                <a:solidFill>
+                  <a:srgbClr val="FFFFFF"/>
+                </a:solidFill>
+              </a:rPr>
+              <a:t>⚔️ 竞争格局对比</a:t>
+            </a:r>
+          </a:p>
+        </p:txBody>
+      </p:sp>
+      <p:graphicFrame>
+        <p:nvGraphicFramePr>
+          <p:cNvPr id="10" name="CompTable"/>
+          <p:cNvGraphicFramePr>
+            <a:graphicFrameLocks noGrp="1"/>
+          </p:cNvGraphicFramePr>
+          <p:nvPr/>
+        </p:nvGraphicFramePr>
+        <p:xfrm>
+          <a:off x="5944560" y="2286000"/>
+          <a:ext cx="5891040" cy="2286000"/>
+        </p:xfrm>
+        <a:graphic>
+          <a:graphicData uri="http://schemas.openxmlformats.org/drawingml/2006/table">
+            <a:tbl>
+              <a:tblPr firstRow="1" bandRow="1">
+                <a:tableStyleId>{5C22544A-7EE6-4342-B048-85BDC9FD1C3A}</a:tableStyleId>
+              </a:tblPr>
+              <a:tblGrid>
+                <a:gridCol w="1500000"/>
+                <a:gridCol w="1500000"/>
+                <a:gridCol w="2891040"/>
+              </a:tblGrid>
+              <a:tr h="320000">
+                <a:tc>
+                  <a:txBody>
+                    <a:bodyPr/>
+                    <a:lstStyle/>
+                    <a:p>
+                      <a:pPr algn="ctr">
+                        <a:defRPr sz="1100" b="1">
+                          <a:solidFill>
+                            <a:srgbClr val="FFFFFF"/>
+                          </a:solidFill>
+                        </a:defRPr>
+                      </a:pPr>
+                      <a:r>
+                        <a:t>维度</a:t>
+                      </a:r>
+                    </a:p>
+                  </a:txBody>
+                  <a:tcPr>
+                    <a:solidFill>
+                      <a:srgbClr val="8B0000"/>
+                    </a:solidFill>
+                  </a:tcPr>
+                </a:tc>
+                <a:tc>
+                  <a:txBody>
+                    <a:bodyPr/>
+                    <a:lstStyle/>
+                    <a:p>
+                      <a:pPr algn="ctr">
+                        <a:defRPr sz="1100" b="1">
+                          <a:solidFill>
+                            <a:srgbClr val="FFFFFF"/>
+                          </a:solidFill>
+                        </a:defRPr>
+                      </a:pPr>
+                      <a:r>
+                        <a:t>腾讯</a:t>
+                      </a:r>
+                    </a:p>
+                  </a:txBody>
+                  <a:tcPr>
+                    <a:solidFill>
+                      <a:srgbClr val="8B0000"/>
+                    </a:solidFill>
+                  </a:tcPr>
+                </a:tc>
+                <a:tc>
+                  <a:txBody>
+                    <a:bodyPr/>
+                    <a:lstStyle/>
+                    <a:p>
+                      <a:pPr algn="ctr">
+                        <a:defRPr sz="1100" b="1">
+                          <a:solidFill>
+                            <a:srgbClr val="FFFFFF"/>
+                          </a:solidFill>
+                        </a:defRPr>
+                      </a:pPr>
+                      <a:r>
+                        <a:t>Meta</a:t>
+                      </a:r>
+                    </a:p>
+                  </a:txBody>
+                  <a:tcPr>
+                    <a:solidFill>
+                      <a:srgbClr val="8B0000"/>
+                    </a:solidFill>
+                  </a:tcPr>
+                </a:tc>
+              </a:tr>
+              <a:tr h="320000">
+                <a:tc>
+                  <a:txBody>
+                    <a:bodyPr/>
+                    <a:lstStyle/>
+                    <a:p>
+                      <a:pPr algn="l">
+                        <a:defRPr sz="1100">
+                          <a:solidFill>
+                            <a:srgbClr val="FFFFFF"/>
+                          </a:solidFill>
+                        </a:defRPr>
+                      </a:pPr>
+                      <a:r>
+                        <a:t>AI策略</a:t>
+                      </a:r>
+                    </a:p>
+                  </a:txBody>
+                  <a:tcPr/>
+                </a:tc>
+                <a:tc>
+                  <a:txBody>
+                    <a:bodyPr/>
+                    <a:lstStyle/>
+                    <a:p>
+                      <a:pPr algn="l">
+                        <a:defRPr sz="1100">
+                          <a:solidFill>
+                            <a:srgbClr val="FFFFFF"/>
+                          </a:solidFill>
+                        </a:defRPr>
+                      </a:pPr>
+                      <a:r>
+                        <a:t>渐进验证，真实场景优先</a:t>
+                      </a:r>
+                    </a:p>
+                  </a:txBody>
+                  <a:tcPr/>
+                </a:tc>
+                <a:tc>
+                  <a:txBody>
+                    <a:bodyPr/>
+                    <a:lstStyle/>
+                    <a:p>
+                      <a:pPr algn="l">
+                        <a:defRPr sz="1100">
+                          <a:solidFill>
+                            <a:srgbClr val="FFFFFF"/>
+                          </a:solidFill>
+                        </a:defRPr>
+                      </a:pPr>
+                      <a:r>
+                        <a:t>All-in 各种热点</a:t>
+                      </a:r>
+                    </a:p>
+                  </a:txBody>
+                  <a:tcPr/>
+                </a:tc>
+              </a:tr>
+              <a:tr h="320000">
+                <a:tc>
+                  <a:txBody>
+                    <a:bodyPr/>
+                    <a:lstStyle/>
+                    <a:p>
+                      <a:pPr algn="l">
+                        <a:defRPr sz="1100">
+                          <a:solidFill>
+                            <a:srgbClr val="FFFFFF"/>
+                          </a:solidFill>
+                        </a:defRPr>
+                      </a:pPr>
+                      <a:r>
+                        <a:t>速度</a:t>
+                      </a:r>
+                    </a:p>
+                  </a:txBody>
+                  <a:tcPr/>
+                </a:tc>
+                <a:tc>
+                  <a:txBody>
+                    <a:bodyPr/>
+                    <a:lstStyle/>
+                    <a:p>
+                      <a:pPr algn="ctr">
+                        <a:defRPr sz="1100">
+                          <a:solidFill>
+                            <a:srgbClr val="00FF00"/>
+                          </a:solidFill>
+                        </a:defRPr>
+                      </a:pPr>
+                      <a:r>
+                        <a:t>慢</a:t>
+                      </a:r>
+                    </a:p>
+                  </a:txBody>
+                  <a:tcPr/>
+                </a:tc>
+                <a:tc>
+                  <a:txBody>
+                    <a:bodyPr/>
+                    <a:lstStyle/>
+                    <a:p>
+                      <a:pPr algn="ctr">
+                        <a:defRPr sz="1100">
+                          <a:solidFill>
+                            <a:srgbClr val="FF6666"/>
+                          </a:solidFill>
+                        </a:defRPr>
+                      </a:pPr>
+                      <a:r>
+                        <a:t>快</a:t>
+                      </a:r>
+                    </a:p>
+                  </a:txBody>
+                  <a:tcPr/>
+                </a:tc>
+              </a:tr>
+              <a:tr h="320000">
+                <a:tc>
+                  <a:txBody>
+                    <a:bodyPr/>
+                    <a:lstStyle/>
+                    <a:p>
+                      <a:pPr algn="l">
+                        <a:defRPr sz="1100">
+                          <a:solidFill>
+                            <a:srgbClr val="FFFFFF"/>
+                          </a:solidFill>
+                        </a:defRPr>
+                      </a:pPr>
+                      <a:r>
+                        <a:t>风险偏好</a:t>
+                      </a:r>
+                    </a:p>
+                  </a:txBody>
+                  <a:tcPr/>
+                </a:tc>
+                <a:tc>
+                  <a:txBody>
+                    <a:bodyPr/>
+                    <a:lstStyle/>
+                    <a:p>
+                      <a:pPr algn="l">
+                        <a:defRPr sz="1100">
+                          <a:solidFill>
+                            <a:srgbClr val="FFFFFF"/>
+                          </a:solidFill>
+                        </a:defRPr>
+                      </a:pPr>
+                      <a:r>
+                        <a:t>低（不成熟方案不上线）</a:t>
+                      </a:r>
+                    </a:p>
+                  </a:txBody>
+                  <a:tcPr/>
+                </a:tc>
+                <a:tc>
+                  <a:txBody>
+                    <a:bodyPr/>
+                    <a:lstStyle/>
+                    <a:p>
+                      <a:pPr algn="l">
+                        <a:defRPr sz="1100">
+                          <a:solidFill>
+                            <a:srgbClr val="FFFFFF"/>
+                          </a:solidFill>
+                        </a:defRPr>
+                      </a:pPr>
+                      <a:r>
+                        <a:t>高（追逐热点踏空风险）</a:t>
+                      </a:r>
+                    </a:p>
+                  </a:txBody>
+                  <a:tcPr/>
+                </a:tc>
+              </a:tr>
+              <a:tr h="320000">
+                <a:tc>
+                  <a:txBody>
+                    <a:bodyPr/>
+                    <a:lstStyle/>
+                    <a:p>
+                      <a:pPr algn="l">
+                        <a:defRPr sz="1100">
+                          <a:solidFill>
+                            <a:srgbClr val="FFFFFF"/>
+                          </a:solidFill>
+                        </a:defRPr>
+                      </a:pPr>
+                      <a:r>
+                        <a:t>护城河</a:t>
+                      </a:r>
+                    </a:p>
+                  </a:txBody>
+                  <a:tcPr/>
+                </a:tc>
+                <a:tc>
+                  <a:txBody>
+                    <a:bodyPr/>
+                    <a:lstStyle/>
+                    <a:p>
+                      <a:pPr algn="l">
+                        <a:defRPr sz="1100">
+                          <a:solidFill>
+                            <a:srgbClr val="00FF00"/>
+                          </a:solidFill>
+                        </a:defRPr>
+                      </a:pPr>
+                      <a:r>
+                        <a:t>验证体系一旦建立极难复制</a:t>
+                      </a:r>
+                    </a:p>
+                  </a:txBody>
+                  <a:tcPr/>
+                </a:tc>
+                <a:tc>
+                  <a:txBody>
+                    <a:bodyPr/>
+                    <a:lstStyle/>
+                    <a:p>
+                      <a:pPr algn="l">
+                        <a:defRPr sz="1100">
+                          <a:solidFill>
+                            <a:srgbClr val="FF6666"/>
+                          </a:solidFill>
+                        </a:defRPr>
+                      </a:pPr>
+                      <a:r>
+                        <a:t>热点分散无护城河</a:t>
+                      </a:r>
+                    </a:p>
+                  </a:txBody>
+                  <a:tcPr/>
+                </a:tc>
+              </a:tr>
+              <a:tr h="320000">
+                <a:tc>
+                  <a:txBody>
+                    <a:bodyPr/>
+                    <a:lstStyle/>
+                    <a:p>
+                      <a:pPr algn="l">
+                        <a:defRPr sz="1100">
+                          <a:solidFill>
+                            <a:srgbClr val="FFFFFF"/>
+                          </a:solidFill>
+                        </a:defRPr>
+                      </a:pPr>
+                      <a:r>
+                        <a:t>Agent爆发概率(2027)</a:t>
+                      </a:r>
+                    </a:p>
+                  </a:txBody>
+                  <a:tcPr/>
+                </a:tc>
+                <a:tc>
+                  <a:txBody>
+                    <a:bodyPr/>
+                    <a:lstStyle/>
+                    <a:p>
+                      <a:pPr algn="ctr">
+                        <a:defRPr sz="1100" b="1">
+                          <a:solidFill>
+                            <a:srgbClr val="00FF00"/>
+                          </a:solidFill>
+                        </a:defRPr>
+                      </a:pPr>
+                      <a:r>
+                        <a:t>60-70%</a:t>
+                      </a:r>
+                    </a:p>
+                  </a:txBody>
+                  <a:tcPr/>
+                </a:tc>
+                <a:tc>
+                  <a:txBody>
+                    <a:bodyPr/>
+                    <a:lstStyle/>
+                    <a:p>
+                      <a:pPr algn="ctr">
+                        <a:defRPr sz="1100">
+                          <a:solidFill>
+                            <a:srgbClr val="AAAAAA"/>
+                          </a:solidFill>
+                        </a:defRPr>
+                      </a:pPr>
+                      <a:r>
+                        <a:t>—</a:t>
+                      </a:r>
+                    </a:p>
+                  </a:txBody>
+                  <a:tcPr/>
+                </a:tc>
+              </a:tr>
+            </a:tbl>
+          </a:graphicData>
+        </a:graphic>
+      </p:graphicFrame>
+      <p:sp>
+        <p:nvSpPr>
+          <p:cNvPr id="11" name="FooterBox"/>
+          <p:cNvSpPr/>
+          <p:nvPr/>
+        </p:nvSpPr>
+        <p:spPr>
+          <a:xfrm>
+            <a:off x="0" y="6400000"/>
+            <a:ext cx="12188952" cy="457600"/>
+          </a:xfrm>
+          <a:prstGeom prst="rect">
+            <a:avLst/>
+          </a:prstGeom>
+          <a:solidFill>
+            <a:srgbClr val="004A8A"/>
+          </a:solidFill>
+          <a:ln>
+            <a:noFill/>
+          </a:ln>
+        </p:spPr>
+        <p:txBody>
+          <a:bodyPr rtlCol="0" anchor="ctr"/>
+          <a:lstStyle/>
+          <a:p>
+            <a:pPr algn="ctr"/>
+            <a:r>
+              <a:rPr sz="1000">
+                <a:solidFill>
+                  <a:srgbClr val="AAAAAA"/>
+                </a:solidFill>
+              </a:rPr>
+              <a:t>数据来源：腾讯官方财报 / 分析师估算 | C Job Day 4</a:t>
+            </a:r>
+          </a:p>
+        </p:txBody>
+      </p:sp>
+    </p:spTree>
+  </p:cSld>
+  <p:clrMapOvr>
+    <a:masterClrMapping/>
+  </p:clrMapOvr>
 </p:sld>
 </file>
 
-<file path=ppt/slides/slide4.xml><?xml version="1.0" encoding="UTF-8" standalone="yes"?>
+<file path=ppt/slides/slide4.xml><?xml version="1.0" encoding="utf-8"?>
 <p:sld xmlns:a="http://schemas.openxmlformats.org/drawingml/2006/main" xmlns:p="http://schemas.openxmlformats.org/presentationml/2006/main" xmlns:r="http://schemas.openxmlformats.org/officeDocument/2006/relationships">
-<p:cSld>
-<p:bg><p:bgPr><a:solidFill><a:srgbClr val="1A1A2E"/></a:solidFill><a:effectLst/></p:bgPr></p:bg>
-<p:spTree>
-<p:nvGrpSpPr><p:cNvPr id="1" name=""/><p:cNvGrpSpPr/><p:nvPr/></p:nvGrpSpPr>
-<p:grpSpPr/>
-<p:sp><p:nvSpPr><p:cNvPr id="2" name="Header Bar"/><p:cNvSpPr/><p:nvPr/></p:nvSpPr>
-<p:spPr><a:xfrm><a:off x="0" y="0"/><a:ext cx="12188952" cy="1097280"/></a:xfrm><a:prstGeom prst="rect"><a:avLst/></a:prstGeom><a:solidFill><a:srgbClr val="004A8A"/></a:solidFill><a:ln><a:noFill/></a:ln></p:spPr>
-<p:txBody><a:bodyPr rtlCol="0" anchor="ctr"/><a:lstStyle/><a:p><a:pPr algn="ctr"/></a:p></p:txBody></p:sp>
-<p:sp><p:nvSpPr><p:cNvPr id="3" name="Title"/><p:cNvSpPr txBox="1"/><p:nvPr/></p:nvSpPr>
-<p:spPr><a:xfrm><a:off x="274320" y="91440"/><a:ext cx="10972800" cy="731520"/></a:xfrm><a:prstGeom prst="rect"><a:avLst/></a:prstGeom><a:noFill/></p:spPr>
-<p:txBody><a:bodyPr wrap="square"><a:spAutoFit/></a:bodyPr><a:lstStyle/><a:p><a:pPr algn="ctr"/><a:r><a:rPr sz="2800" b="1" i="0"><a:solidFill><a:srgbClr val="FFFFFF"/></a:solidFill></a:rPr><a:t>腾讯AI战略研究 — C Job Day 5 投资风险 &amp; 建议总结</a:t></a:r></a:p></p:txBody></p:sp>
-<p:sp><p:nvSpPr><p:cNvPr id="4" name="Subtitle"/><p:cNvSpPr txBox="1"/><p:nvPr/></p:nvSpPr>
-<p:spPr><a:xfrm><a:off x="274320" y="1188720"/><a:ext cx="10972800" cy="365760"/></a:xfrm><a:prstGeom prst="rect"><a:avLst/></a:prstGeom><a:noFill/></p:spPr>
-<p:txBody><a:bodyPr wrap="square"><a:spAutoFit/></a:bodyPr><a:lstStyle/><a:p><a:pPr algn="ctr"/><a:r><a:rPr sz="1400" b="0" i="1"><a:solidFill><a:srgbClr val="D4AF37"/></a:solidFill></a:rPr><a:t>风险评估 · 情景分析 · 投资建议总结</a:t></a:r></a:p></p:txBody></p:sp>
-<p:sp><p:nvSpPr><p:cNvPr id="5" name="SectionBox1"/><p:cNvSpPr/><p:nvPr/></p:nvSpPr>
-<p:spPr><a:xfrm><a:off x="274320" y="1737360"/><a:ext cx="3657600" cy="457200"/></a:xfrm><a:prstGeom prst="rect"><a:avLst/></a:prstGeom><a:solidFill><a:srgbClr val="8B0000"/></a:solidFill><a:ln><a:noFill/></a:ln></p:spPr>
-<p:txBody><a:bodyPr rtlCol="0" anchor="ctr"/><a:lstStyle/><a:p><a:pPr algn="ctr"/></a:p></p:txBody></p:sp>
-<p:sp><p:nvSpPr><p:cNvPr id="6" name="SectionTitle1"/><p:cNvSpPr txBox="1"/><p:nvPr/></p:nvSpPr>
-<p:spPr><a:xfrm><a:off x="365760" y="1783080"/><a:ext cx="3483360" cy="365760"/></a:xfrm><a:prstGeom prst="rect"><a:avLst/></a:prstGeom><a:noFill/></p:spPr>
-<p:txBody><a:bodyPr wrap="square"><a:spAutoFit/></a:bodyPr><a:lstStyle/><a:p><a:pPr algn="l"/><a:r><a:rPr sz="1400" b="1" i="0"><a:solidFill><a:srgbClr val="FFFFFF"/></a:solidFill></a:rPr><a:t>⚠️ 投资风险</a:t></a:r></a:p></p:txBody></p:sp>
-<p:graphicFrame><p:nvGraphicFramePr><p:cNvPr id="7" name="RiskTable"/><p:cNvGraphicFramePr><a:graphicFrameLocks noGrp="1"/></p:cNvGraphicFramePr><p:nvPr/></p:nvGraphicFramePr>
-<p:xfrm><a:off x="274320" y="2286000"/><a:ext cx="3657600" cy="2286000"/></p:xfrm>
-<a:graphic><a:graphicData uri="http://schemas.openxmlformats.org/drawingml/2006/table"><a:tbl><a:tblPr firstRow="1" bandRow="1"><a:tableStyleId>{5C22544A-7EE6-4342-B048-85BDC9FD1C3A}</a:tableStyleId></a:tblPr>
-<a:tblGrid><a:gridCol w="1600000"/><a:gridCol w="2057600"/></a:tblGrid>
-<a:tr h="320000"><a:tc><a:txBody><a:bodyPr/><a:lstStyle/><a:p><a:pPr algn="ctr"><a:defRPr sz="1100" b="1"><a:solidFill><a:srgbClr val="FFFFFF"/></a:solidFill></a:defRPr></a:pPr><a:r><a:t>风险类型</a:t></a:r></a:p></a:txBody><a:tcPr><a:solidFill><a:srgbClr val="8B0000"/></a:solidFill></a:tcPr></a:tc>
-<a:tc><a:txBody><a:bodyPr/><a:lstStyle/><a:p><a:pPr algn="ctr"><a:defRPr sz="1100" b="1"><a:solidFill><a:srgbClr val="FFFFFF"/></a:solidFill></a:defRPr></a:pPr><a:r><a:t>描述</a:t></a:r></a:p></a:txBody><a:tcPr><a:solidFill><a:srgbClr val="8B0000"/></a:solidFill></a:tcPr></a:tc></a:tr>
-<a:tr h="320000"><a:tc><a:txBody><a:bodyPr/><a:lstStyle/><a:p><a:pPr algn="l"><a:defRPr sz="1100"><a:solidFill><a:srgbClr val="FFFFFF"/></a:solidFill></a:defRPr></a:pPr><a:r><a:t>监管风险</a:t></a:r></a:p></a:txBody><a:tcPr/></a:tc><a:tc><a:txBody><a:bodyPr/><a:lstStyle/><a:p><a:pPr algn="l"><a:defRPr sz="1100"><a:solidFill><a:srgbClr val="FFFFFF"/></a:solidFill></a:defRPr></a:pPr><a:r><a:t>AI监管政策收紧，数据合规要求提升</a:t></a:r></a:p></a:txBody><a:tcPr/></a:tc></a:tr>
-<a:tr h="320000"><a:tc><a:txBody><a:bodyPr/><a:lstStyle/><a:p><a:pPr algn="l"><a:defRPr sz="1100"><a:solidFill><a:srgbClr val="FFFFFF"/></a:solidFill></a:defRPr></a:pPr><a:r><a:t>竞争风险</a:t></a:r></a:p></a:txBody><a:tcPr/></a:tc><a:tc><a:txBody><a:bodyPr/><a:lstStyle/><a:p><a:pPr algn="l"><a:defRPr sz="1100"><a:solidFill><a:srgbClr val="FFFFFF"/></a:solidFill></a:defRPr></a:pPr><a:r><a:t>字节/阿里AI产品快速迭代，抢占用户时间</a:t></a:r></a:p></a:txBody><a:tcPr/></a:tc></a:tr>
-<a:tr h="320000"><a:tc><a:txBody><a:bodyPr/><a:lstStyle/><a:p><a:pPr algn="l"><a:defRPr sz="1100"><a:solidFill><a:srgbClr val="FFFFFF"/></a:solidFill></a:defRPr></a:pPr><a:r><a:t>技术风险</a:t></a:r></a:p></a:txBody><a:tcPr/></a:tc><a:tc><a:txBody><a:bodyPr/><a:lstStyle/><a:p><a:pPr algn="l"><a:defRPr sz="1100"><a:solidFill><a:srgbClr val="FFFFFF"/></a:solidFill></a:defRPr></a:pPr><a:r><a:t>Hy3落地效果不及预期，Agent用户粘性低</a:t></a:r></a:p></a:txBody><a:tcPr/></a:tc></a:tr>
-<a:tr h="320000"><a:tc><a:txBody><a:bodyPr/><a:lstStyle/><a:p><a:pPr algn="l"><a:defRPr sz="1100"><a:solidFill><a:srgbClr val="FFFFFF"/></a:solidFill></a:defRPr></a:pPr><a:r><a:t>变现风险</a:t></a:r></a:p></a:txBody><a:tcPr/></a:tc><a:tc><a:txBody><a:bodyPr/><a:lstStyle/><a:p><a:pPr algn="l"><a:defRPr sz="1100"><a:solidFill><a:srgbClr val="FFFFFF"/></a:solidFill></a:defRPr></a:pPr><a:r><a:t>AI付费模式在中国市场接受度待验证</a:t></a:r></a:p></a:txBody><a:tcPr/></a:tc></a:tr>
-<a:tr h="320000"><a:tc><a:txBody><a:bodyPr/><a:lstStyle/><a:p><a:pPr algn="l"><a:defRPr sz="1100"><a:solidFill><a:srgbClr val="FFFFFF"/></a:solidFill></a:defRPr></a:pPr><a:r><a:t>宏观风险</a:t></a:r></a:p></a:txBody><a:tcPr/></a:tc><a:tc><a:txBody><a:bodyPr/><a:lstStyle/><a:p><a:pPr algn="l"><a:defRPr sz="1100"><a:solidFill><a:srgbClr val="FFFFFF"/></a:solidFill></a:defRPr></a:pPr><a:r><a:t>中国经济复苏放缓，消费互联网广告收入承压</a:t></a:r></a:p></a:txBody><a:tcPr/></a:tc></a:tr>
-</a:tbl></a:graphic></p:graphicFrame>
-<p:sp><p:nvSpPr><p:cNvPr id="8" name="SectionBox2"/><p:cNvSpPr/><p:nvPr/></p:nvSpPr>
-<p:spPr><a:xfrm><a:off x="4114560" y="1737360"/><a:ext cx="3657600" cy="457200"/></a:xfrm><a:prstGeom prst="rect"><a:avLst/></a:prstGeom><a:solidFill><a:srgbClr val="D4AF37"/></a:solidFill><a:ln><a:noFill/></a:ln></p:spPr>
-<p:txBody><a:bodyPr rtlCol="0" anchor="ctr"/><a:lstStyle/><a:p><a:pPr algn="ctr"/></a:p></p:txBody></p:sp>
-<p:sp><p:nvSpPr><p:cNvPr id="9" name="SectionTitle2"/><p:cNvSpPr txBox="1"/><p:nvPr/></p:nvSpPr>
-<p:spPr><a:xfrm><a:off x="4204560" y="1783080"/><a:ext cx="3483360" cy="365760"/></a:xfrm><a:prstGeom prst="rect"><a:avLst/></a:prstGeom><a:noFill/></p:spPr>
-<p:txBody><a:bodyPr wrap="square"><a:spAutoFit/></a:bodyPr><a:lstStyle/><a:p><a:pPr algn="l"/><a:r><a:rPr sz="1400" b="1" i="0"><a:solidFill><a:srgbClr val="1A1A2E"/></a:solidFill></a:rPr><a:t>📊 情景分析总结</a:t></a:r></a:p></p:txBody></p:sp>
-<p:graphicFrame><p:nvGraphicFramePr><p:cNvPr id="10" name="ScenarioTable"/><p:cNvGraphicFramePr><a:graphicFrameLocks noGrp="1"/></p:cNvGraphicFramePr><p:nvPr/></p:nvGraphicFramePr>
-<p:xfrm><a:off x="4114560" y="2286000"/><a:ext cx="3657600" cy="2286000"/></p:xfrm>
-<a:graphic><a:graphicData uri="http://schemas.openxmlformats.org/drawingml/2006/table"><a:tbl><a:tblPr firstRow="1" bandRow="1"><a:tableStyleId>{5C22544A-7EE6-4342-B048-85BDC9FD1C3A}</a:tableStyleId></a:tblPr>
-<a:tblGrid><a:gridCol w="1000000"/><a:gridCol w="1300000"/><a:gridCol w="1357600"/></a:tblGrid>
-<a:tr h="320000"><a:tc><a:txBody><a:bodyPr/><a:lstStyle/><a:p><a:pPr algn="ctr"><a:defRPr sz="1100" b="1"><a:solidFill><a:srgbClr val="FFFFFF"/></a:solidFill></a:defRPr></a:pPr><a:r><a:t>情景</a:t></a:r></a:p></a:txBody><a:tcPr><a:solidFill><a:srgbClr val="D4AF37"/></a:solidFill></a:tcPr></a:tc>
-<a:tc><a:txBody><a:bodyPr/><a:lstStyle/><a:p><a:pPr algn="ctr"><a:defRPr sz="1100" b="1"><a:solidFill><a:srgbClr val="1A1A2E"/></a:solidFill></a:defRPr></a:pPr><a:r><a:t>目标价</a:t></a:r></a:p></a:txBody><a:tcPr><a:solidFill><a:srgbClr val="D4AF37"/></a:solidFill></a:tcPr></a:tc>
-<a:tc><a:txBody><a:bodyPr/><a:lstStyle/><a:p><a:pPr algn="ctr"><a:defRPr sz="1100" b="1"><a:solidFill><a:srgbClr val="1A1A2E"/></a:solidFill></a:defRPr></a:pPr><a:r><a:t>潜在涨幅</a:t></a:r></a:p></a:txBody><a:tcPr><a:solidFill><a:srgbClr val="D4AF37"/></a:solidFill></a:tcPr></a:tc></a:tr>
-<a:tr h="320000"><a:tc><a:txBody><a:bodyPr/><a:lstStyle/><a:p><a:pPr algn="ctr"><a:defRPr sz="1100" b="1"><a:solidFill><a:srgbClr val="00FF00"/></a:solidFill></a:defRPr></a:pPr><a:r><a:t>Bull</a:t></a:r></a:p></a:txBody><a:tcPr/></a:tc><a:tc><a:txBody><a:bodyPr/><a:lstStyle/><a:p><a:pPr algn="ctr"><a:defRPr sz="1100" b="1"><a:solidFill><a:srgbClr val="00FF00"/></a:solidFill></a:defRPr></a:pPr><a:r><a:t>706港元</a:t></a:r></a:p></a:txBody><a:tcPr/></a:tc><a:tc><a:txBody><a:bodyPr/><a:lstStyle/><a:p><a:pPr algn="ctr"><a:defRPr sz="1100" b="1"><a:solidFill><a:srgbClr val="00FF00"/></a:solidFill></a:defRPr></a:pPr><a:r><a:t>+61%</a:t></a:r></a:p></a:txBody><a:tcPr/></a:tc></a:tr>
-<a:tr h="320000"><a:tc><a:txBody><a:bodyPr/><a:lstStyle/><a:p><a:pPr algn="ctr"><a:defRPr sz="1100" b="1"><a:solidFill><a:srgbClr val="D4AF37"/></a:solidFill></a:defRPr></a:pPr><a:r><a:t>Base</a:t></a:r></a:p></a:txBody><a:tcPr/></a:tc><a:tc><a:txBody><a:bodyPr/><a:lstStyle/><a:p><a:pPr algn="ctr"><a:defRPr sz="1100" b="1"><a:solidFill><a:srgbClr val="D4AF37"/></a:solidFill></a:defRPr></a:pPr><a:r><a:t>545港元</a:t></a:r></a:p></a:txBody><a:tcPr/></a:tc><a:tc><a:txBody><a:bodyPr/><a:lstStyle/><a:p><a:pPr algn="ctr"><a:defRPr sz="1100" b="1"><a:solidFill><a:srgbClr val="D4AF37"/></a:solidFill></a:defRPr></a:pPr><a:r><a:t>+24%</a:t></a:r></a:p></a:txBody><a:tcPr/></a:tc></a:tr>
-<a:tr h="320000"><a:tc><a:txBody><a:bodyPr/><a:lstStyle/><a:p><a:pPr algn="ctr"><a:defRPr sz="1100" b="1"><a:solidFill><a:srgbClr val="FF6666"/></a:solidFill></a:defRPr></a:pPr><a:r><a:t>Bear</a:t></a:r></a:p></a:txBody><a:tcPr/></a:tc><a:tc><a:txBody><a:bodyPr/><a:lstStyle/><a:p><a:pPr algn="ctr"><a:defRPr sz="1100" b="1"><a:solidFill><a:srgbClr val="FF6666"/></a:solidFill></a:defRPr></a:pPr><a:r><a:t>366港元</a:t></a:r></a:p></a:txBody><a:tcPr/></a:tc><a:tc><a:txBody><a:bodyPr/><a:lstStyle/><a:p><a:pPr algn="ctr"><a:defRPr sz="1100" b="1"><a:solidFill><a:srgbClr val="FF6666"/></a:solidFill></a:defRPr></a:pPr><a:r><a:t>-17%</a:t></a:r></a:p></a:txBody><a:tcPr/></a:tc></a:tr>
-<a:tr h="320000"><a:tc><a:txBody><a:bodyPr/><a:lstStyle/><a:p><a:pPr algn="l"><a:defRPr sz="1100"><a:solidFill><a:srgbClr val="FFFFFF"/></a:solidFill></a:defRPr></a:pPr><a:r><a:t>概率假设</a:t></a:r></a:p></a:txBody><a:tcPr/></a:tc><a:tc><a:txBody><a:bodyPr/><a:lstStyle/><a:p><a:pPr algn="l"><a:defRPr sz="1100"><a:solidFill><a:srgbClr val="FFFFFF"/></a:solidFill></a:defRPr></a:pPr><a:r><a:t>各1/3基准</a:t></a:r></a:p></a:txBody><a:tcPr/></a:tc><a:tc><a:txBody><a:bodyPr/><a:lstStyle/><a:p><a:pPr algn="l"><a:defRPr sz="1100"><a:solidFill><a:srgbClr val="FFFFFF"/></a:solidFill></a:defRPr></a:pPr><a:r><a:t>隐含期望值≈539</a:t></a:r></a:p></a:txBody><a:tcPr/></a:tc></a:tr>
-</a:tbl></a:graphic></p:graphicFrame>
-<p:sp><p:nvSpPr><p:cNvPr id="11" name="SectionBox3"/><p:cNvSpPr/><p:nvPr/></p:nvSpPr>
-<p:spPr><a:xfrm><a:off x="7942320" y="1737360"/><a:ext cx="4114560" cy="457200"/></a:xfrm><a:prstGeom prst="rect"><a:avLst/></a:prstGeom><a:solidFill><a:srgbClr val="004A8A"/></a:solidFill><a:ln><a:noFill/></a:ln></p:spPr>
-<p:txBody><a:bodyPr rtlCol="0" anchor="ctr"/><a:lstStyle/><a:p><a:pPr algn="ctr"/></a:p></p:txBody></p:sp>
-<p:sp><p:nvSpPr><p:cNvPr id="12" name="SectionTitle3"/><p:cNvSpPr txBox="1"/><p:nvPr/></p:nvSpPr>
-<p:spPr><a:xfrm><a:off x="8032320" y="1783080"/><a:ext cx="3940320" cy="365760"/></a:xfrm><a:prstGeom prst="rect"><a:avLst/></a:prstGeom><a:noFill/></p:spPr>
-<p:txBody><a:bodyPr wrap="square"><a:spAutoFit/></a:bodyPr><a:lstStyle/><a:p><a:pPr algn="l"/><a:r><a:rPr sz="1400" b="1" i="0"><a:solidFill><a:srgbClr val="FFFFFF"/></a:solidFill></a:rPr><a:t>✅ 投资建议总结</a:t></a:r></a:p></p:txBody></p:sp>
-<p:sp><p:nvSpPr><p:cNvPr id="13" name="AdviceBox"/><p:cNvSpPr txBox="1"/><p:nvPr/></p:nvSpPr>
-<p:spPr><a:xfrm><a:off x="7942320" y="2286000"/><a:ext cx="4114560" cy="2286000"/></a:xfrm><a:prstGeom prst="rect"><a:avLst/></a:prstGeom><a:solidFill><a:srgbClr val="002040"/></a:solidFill><a:ln><a:noFill/></a:ln></p:spPr>
-<p:txBody><a:bodyPr wrap="square" rtlCol="0"><a:spAutoFit/></a:bodyPr><a:lstStyle/>
-<a:p><a:pPr algn="l"/><a:r><a:rPr sz="1200" b="1"><a:solidFill><a:srgbClr val="00FF00"/></a:solidFill></a:rPr><a:t>【中期】谨慎买入</a:t></a:r></a:p>
-<a:p><a:pPr algn="l"/><a:r><a:rPr sz="1100"><a:solidFill><a:srgbClr val="FFFFFF"/></a:solidFill></a:rPr><a:t>• 当前PE 12倍低于历史中枢，安全边际充足</a:t></a:r></a:p>
-<a:p><a:pPr algn="l"/><a:r><a:rPr sz="1100"><a:solidFill><a:srgbClr val="FFFFFF"/></a:solidFill></a:rPr><a:t>• 目标价470-520港元，Base情景+24%</a:t></a:r></a:p>
-<a:p><a:pPr algn="l"/><a:r><a:rPr sz="1100"><a:solidFill><a:srgbClr val="FFFFFF"/></a:solidFill></a:rPr><a:t>• 等待催化剂确认（微信Agent/AI变现）</a:t></a:r></a:p>
-<a:p><a:pPr algn="l"/><a:endParaRPr lang="en-US"/></a:p>
-<a:p><a:pPr algn="l"/><a:r><a:rPr sz="1200" b="1"><a:solidFill><a:srgbClr val="00FF00"/></a:solidFill></a:rPr><a:t>【长期】强烈买入</a:t></a:r></a:p>
-<a:p><a:pPr algn="l"/><a:r><a:rPr sz="1100"><a:solidFill><a:srgbClr val="FFFFFF"/></a:solidFill></a:rPr><a:t>• Agent生态一旦成型，护城河极难复制</a:t></a:r></a:p>
-<a:p><a:pPr algn="l"/><a:r><a:rPr sz="1100"><a:solidFill><a:srgbClr val="FFFFFF"/></a:solidFill></a:rPr><a:t>• Bull情景706港元(+61%)，时间换空间</a:t></a:r></a:p>
-<a:p><a:pPr algn="l"/><a:r><a:rPr sz="1100"><a:solidFill><a:srgbClr val="FFFFFF"/></a:solidFill></a:rPr><a:t>• 腾讯是中国AI应用端最强护城河</a:t></a:r></a:p>
-</p:txBody></p:sp>
-<p:sp><p:nvSpPr><p:cNvPr id="14" name="FooterBox"/><p:cNvSpPr/><p:nvPr/></p:nvSpPr>
-<p:spPr><a:xfrm><a:off x="0" y="6400000"/><a:ext cx="12188952" cy="457600"/></a:xfrm><a:prstGeom prst="rect"><a:avLst/></a:prstGeom><a:solidFill><a:srgbClr val="004A8A"/></a:solidFill><a:ln><a:noFill/></a:ln></p:spPr>
-<p:txBody><a:bodyPr rtlCol="0" anchor="ctr"/><a:lstStyle/><a:p><a:pPr algn="ctr"/><a:r><a:rPr sz="1000"><a:solidFill><a:srgbClr val="AAAAAA"/></a:solidFill></a:rPr><a:t>数据来源：腾讯官方财报 / 分析师估算 | C Job Day 5 | CONFIDENTIAL</a:t></a:r></a:p></p:txBody></p:sp>
-</p:spTree>
-</p:cSld>
-<p:clrMapOvr><a:masterClrMapping/></p:clrMapOvr>
+  <p:cSld>
+    <p:bg>
+      <p:bgPr>
+        <a:solidFill>
+          <a:srgbClr val="1A1A2E"/>
+        </a:solidFill>
+        <a:effectLst/>
+      </p:bgPr>
+    </p:bg>
+    <p:spTree>
+      <p:nvGrpSpPr>
+        <p:cNvPr id="1" name=""/>
+        <p:cNvGrpSpPr/>
+        <p:nvPr/>
+      </p:nvGrpSpPr>
+      <p:grpSpPr/>
+      <p:sp>
+        <p:nvSpPr>
+          <p:cNvPr id="2" name="Header Bar"/>
+          <p:cNvSpPr/>
+          <p:nvPr/>
+        </p:nvSpPr>
+        <p:spPr>
+          <a:xfrm>
+            <a:off x="0" y="0"/>
+            <a:ext cx="12188952" cy="1097280"/>
+          </a:xfrm>
+          <a:prstGeom prst="rect">
+            <a:avLst/>
+          </a:prstGeom>
+          <a:solidFill>
+            <a:srgbClr val="004A8A"/>
+          </a:solidFill>
+          <a:ln>
+            <a:noFill/>
+          </a:ln>
+        </p:spPr>
+        <p:txBody>
+          <a:bodyPr rtlCol="0" anchor="ctr"/>
+          <a:lstStyle/>
+          <a:p>
+            <a:pPr algn="ctr"/>
+          </a:p>
+        </p:txBody>
+      </p:sp>
+      <p:sp>
+        <p:nvSpPr>
+          <p:cNvPr id="3" name="Title"/>
+          <p:cNvSpPr txBox="1"/>
+          <p:nvPr/>
+        </p:nvSpPr>
+        <p:spPr>
+          <a:xfrm>
+            <a:off x="274320" y="91440"/>
+            <a:ext cx="10972800" cy="731520"/>
+          </a:xfrm>
+          <a:prstGeom prst="rect">
+            <a:avLst/>
+          </a:prstGeom>
+          <a:noFill/>
+        </p:spPr>
+        <p:txBody>
+          <a:bodyPr wrap="square">
+            <a:spAutoFit/>
+          </a:bodyPr>
+          <a:lstStyle/>
+          <a:p>
+            <a:pPr algn="ctr"/>
+            <a:r>
+              <a:rPr sz="2800" b="1" i="0">
+                <a:solidFill>
+                  <a:srgbClr val="FFFFFF"/>
+                </a:solidFill>
+              </a:rPr>
+              <a:t>腾讯AI战略研究 — C Job Day 5 投资风险 &amp; 建议总结</a:t>
+            </a:r>
+          </a:p>
+        </p:txBody>
+      </p:sp>
+      <p:sp>
+        <p:nvSpPr>
+          <p:cNvPr id="4" name="Subtitle"/>
+          <p:cNvSpPr txBox="1"/>
+          <p:nvPr/>
+        </p:nvSpPr>
+        <p:spPr>
+          <a:xfrm>
+            <a:off x="274320" y="1188720"/>
+            <a:ext cx="10972800" cy="365760"/>
+          </a:xfrm>
+          <a:prstGeom prst="rect">
+            <a:avLst/>
+          </a:prstGeom>
+          <a:noFill/>
+        </p:spPr>
+        <p:txBody>
+          <a:bodyPr wrap="square">
+            <a:spAutoFit/>
+          </a:bodyPr>
+          <a:lstStyle/>
+          <a:p>
+            <a:pPr algn="ctr"/>
+            <a:r>
+              <a:rPr sz="1400" b="0" i="1">
+                <a:solidFill>
+                  <a:srgbClr val="D4AF37"/>
+                </a:solidFill>
+              </a:rPr>
+              <a:t>风险评估 · 情景分析 · 投资建议总结</a:t>
+            </a:r>
+          </a:p>
+        </p:txBody>
+      </p:sp>
+      <p:sp>
+        <p:nvSpPr>
+          <p:cNvPr id="5" name="SectionBox1"/>
+          <p:cNvSpPr/>
+          <p:nvPr/>
+        </p:nvSpPr>
+        <p:spPr>
+          <a:xfrm>
+            <a:off x="274320" y="1737360"/>
+            <a:ext cx="3657600" cy="457200"/>
+          </a:xfrm>
+          <a:prstGeom prst="rect">
+            <a:avLst/>
+          </a:prstGeom>
+          <a:solidFill>
+            <a:srgbClr val="8B0000"/>
+          </a:solidFill>
+          <a:ln>
+            <a:noFill/>
+          </a:ln>
+        </p:spPr>
+        <p:txBody>
+          <a:bodyPr rtlCol="0" anchor="ctr"/>
+          <a:lstStyle/>
+          <a:p>
+            <a:pPr algn="ctr"/>
+          </a:p>
+        </p:txBody>
+      </p:sp>
+      <p:sp>
+        <p:nvSpPr>
+          <p:cNvPr id="6" name="SectionTitle1"/>
+          <p:cNvSpPr txBox="1"/>
+          <p:nvPr/>
+        </p:nvSpPr>
+        <p:spPr>
+          <a:xfrm>
+            <a:off x="365760" y="1783080"/>
+            <a:ext cx="3483360" cy="365760"/>
+          </a:xfrm>
+          <a:prstGeom prst="rect">
+            <a:avLst/>
+          </a:prstGeom>
+          <a:noFill/>
+        </p:spPr>
+        <p:txBody>
+          <a:bodyPr wrap="square">
+            <a:spAutoFit/>
+          </a:bodyPr>
+          <a:lstStyle/>
+          <a:p>
+            <a:pPr algn="l"/>
+            <a:r>
+              <a:rPr sz="1400" b="1" i="0">
+                <a:solidFill>
+                  <a:srgbClr val="FFFFFF"/>
+                </a:solidFill>
+              </a:rPr>
+              <a:t>⚠️ 投资风险</a:t>
+            </a:r>
+          </a:p>
+        </p:txBody>
+      </p:sp>
+      <p:graphicFrame>
+        <p:nvGraphicFramePr>
+          <p:cNvPr id="7" name="RiskTable"/>
+          <p:cNvGraphicFramePr>
+            <a:graphicFrameLocks noGrp="1"/>
+          </p:cNvGraphicFramePr>
+          <p:nvPr/>
+        </p:nvGraphicFramePr>
+        <p:xfrm>
+          <a:off x="274320" y="2286000"/>
+          <a:ext cx="3657600" cy="2286000"/>
+        </p:xfrm>
+        <a:graphic>
+          <a:graphicData uri="http://schemas.openxmlformats.org/drawingml/2006/table">
+            <a:tbl>
+              <a:tblPr firstRow="1" bandRow="1">
+                <a:tableStyleId>{5C22544A-7EE6-4342-B048-85BDC9FD1C3A}</a:tableStyleId>
+              </a:tblPr>
+              <a:tblGrid>
+                <a:gridCol w="1600000"/>
+                <a:gridCol w="2057600"/>
+              </a:tblGrid>
+              <a:tr h="320000">
+                <a:tc>
+                  <a:txBody>
+                    <a:bodyPr/>
+                    <a:lstStyle/>
+                    <a:p>
+                      <a:pPr algn="ctr">
+                        <a:defRPr sz="1100" b="1">
+                          <a:solidFill>
+                            <a:srgbClr val="FFFFFF"/>
+                          </a:solidFill>
+                        </a:defRPr>
+                      </a:pPr>
+                      <a:r>
+                        <a:t>风险类型</a:t>
+                      </a:r>
+                    </a:p>
+                  </a:txBody>
+                  <a:tcPr>
+                    <a:solidFill>
+                      <a:srgbClr val="8B0000"/>
+                    </a:solidFill>
+                  </a:tcPr>
+                </a:tc>
+                <a:tc>
+                  <a:txBody>
+                    <a:bodyPr/>
+                    <a:lstStyle/>
+                    <a:p>
+                      <a:pPr algn="ctr">
+                        <a:defRPr sz="1100" b="1">
+                          <a:solidFill>
+                            <a:srgbClr val="FFFFFF"/>
+                          </a:solidFill>
+                        </a:defRPr>
+                      </a:pPr>
+                      <a:r>
+                        <a:t>描述</a:t>
+                      </a:r>
+                    </a:p>
+                  </a:txBody>
+                  <a:tcPr>
+                    <a:solidFill>
+                      <a:srgbClr val="8B0000"/>
+                    </a:solidFill>
+                  </a:tcPr>
+                </a:tc>
+              </a:tr>
+              <a:tr h="320000">
+                <a:tc>
+                  <a:txBody>
+                    <a:bodyPr/>
+                    <a:lstStyle/>
+                    <a:p>
+                      <a:pPr algn="l">
+                        <a:defRPr sz="1100">
+                          <a:solidFill>
+                            <a:srgbClr val="FFFFFF"/>
+                          </a:solidFill>
+                        </a:defRPr>
+                      </a:pPr>
+                      <a:r>
+                        <a:t>监管风险</a:t>
+                      </a:r>
+                    </a:p>
+                  </a:txBody>
+                  <a:tcPr/>
+                </a:tc>
+                <a:tc>
+                  <a:txBody>
+                    <a:bodyPr/>
+                    <a:lstStyle/>
+                    <a:p>
+                      <a:pPr algn="l">
+                        <a:defRPr sz="1100">
+                          <a:solidFill>
+                            <a:srgbClr val="FFFFFF"/>
+                          </a:solidFill>
+                        </a:defRPr>
+                      </a:pPr>
+                      <a:r>
+                        <a:t>AI监管政策收紧，数据合规要求提升</a:t>
+                      </a:r>
+                    </a:p>
+                  </a:txBody>
+                  <a:tcPr/>
+                </a:tc>
+              </a:tr>
+              <a:tr h="320000">
+                <a:tc>
+                  <a:txBody>
+                    <a:bodyPr/>
+                    <a:lstStyle/>
+                    <a:p>
+                      <a:pPr algn="l">
+                        <a:defRPr sz="1100">
+                          <a:solidFill>
+                            <a:srgbClr val="FFFFFF"/>
+                          </a:solidFill>
+                        </a:defRPr>
+                      </a:pPr>
+                      <a:r>
+                        <a:t>竞争风险</a:t>
+                      </a:r>
+                    </a:p>
+                  </a:txBody>
+                  <a:tcPr/>
+                </a:tc>
+                <a:tc>
+                  <a:txBody>
+                    <a:bodyPr/>
+                    <a:lstStyle/>
+                    <a:p>
+                      <a:pPr algn="l">
+                        <a:defRPr sz="1100">
+                          <a:solidFill>
+                            <a:srgbClr val="FFFFFF"/>
+                          </a:solidFill>
+                        </a:defRPr>
+                      </a:pPr>
+                      <a:r>
+                        <a:t>字节/阿里AI产品快速迭代，抢占用户时间</a:t>
+                      </a:r>
+                    </a:p>
+                  </a:txBody>
+                  <a:tcPr/>
+                </a:tc>
+              </a:tr>
+              <a:tr h="320000">
+                <a:tc>
+                  <a:txBody>
+                    <a:bodyPr/>
+                    <a:lstStyle/>
+                    <a:p>
+                      <a:pPr algn="l">
+                        <a:defRPr sz="1100">
+                          <a:solidFill>
+                            <a:srgbClr val="FFFFFF"/>
+                          </a:solidFill>
+                        </a:defRPr>
+                      </a:pPr>
+                      <a:r>
+                        <a:t>技术风险</a:t>
+                      </a:r>
+                    </a:p>
+                  </a:txBody>
+                  <a:tcPr/>
+                </a:tc>
+                <a:tc>
+                  <a:txBody>
+                    <a:bodyPr/>
+                    <a:lstStyle/>
+                    <a:p>
+                      <a:pPr algn="l">
+                        <a:defRPr sz="1100">
+                          <a:solidFill>
+                            <a:srgbClr val="FFFFFF"/>
+                          </a:solidFill>
+                        </a:defRPr>
+                      </a:pPr>
+                      <a:r>
+                        <a:t>Hy3落地效果不及预期，Agent用户粘性低</a:t>
+                      </a:r>
+                    </a:p>
+                  </a:txBody>
+                  <a:tcPr/>
+                </a:tc>
+              </a:tr>
+              <a:tr h="320000">
+                <a:tc>
+                  <a:txBody>
+                    <a:bodyPr/>
+                    <a:lstStyle/>
+                    <a:p>
+                      <a:pPr algn="l">
+                        <a:defRPr sz="1100">
+                          <a:solidFill>
+                            <a:srgbClr val="FFFFFF"/>
+                          </a:solidFill>
+                        </a:defRPr>
+                      </a:pPr>
+                      <a:r>
+                        <a:t>变现风险</a:t>
+                      </a:r>
+                    </a:p>
+                  </a:txBody>
+                  <a:tcPr/>
+                </a:tc>
+                <a:tc>
+                  <a:txBody>
+                    <a:bodyPr/>
+                    <a:lstStyle/>
+                    <a:p>
+                      <a:pPr algn="l">
+                        <a:defRPr sz="1100">
+                          <a:solidFill>
+                            <a:srgbClr val="FFFFFF"/>
+                          </a:solidFill>
+                        </a:defRPr>
+                      </a:pPr>
+                      <a:r>
+                        <a:t>AI付费模式在中国市场接受度待验证</a:t>
+                      </a:r>
+                    </a:p>
+                  </a:txBody>
+                  <a:tcPr/>
+                </a:tc>
+              </a:tr>
+              <a:tr h="320000">
+                <a:tc>
+                  <a:txBody>
+                    <a:bodyPr/>
+                    <a:lstStyle/>
+                    <a:p>
+                      <a:pPr algn="l">
+                        <a:defRPr sz="1100">
+                          <a:solidFill>
+                            <a:srgbClr val="FFFFFF"/>
+                          </a:solidFill>
+                        </a:defRPr>
+                      </a:pPr>
+                      <a:r>
+                        <a:t>宏观风险</a:t>
+                      </a:r>
+                    </a:p>
+                  </a:txBody>
+                  <a:tcPr/>
+                </a:tc>
+                <a:tc>
+                  <a:txBody>
+                    <a:bodyPr/>
+                    <a:lstStyle/>
+                    <a:p>
+                      <a:pPr algn="l">
+                        <a:defRPr sz="1100">
+                          <a:solidFill>
+                            <a:srgbClr val="FFFFFF"/>
+                          </a:solidFill>
+                        </a:defRPr>
+                      </a:pPr>
+                      <a:r>
+                        <a:t>中国经济复苏放缓，消费互联网广告收入承压</a:t>
+                      </a:r>
+                    </a:p>
+                  </a:txBody>
+                  <a:tcPr/>
+                </a:tc>
+              </a:tr>
+            </a:tbl>
+          </a:graphicData>
+        </a:graphic>
+      </p:graphicFrame>
+      <p:sp>
+        <p:nvSpPr>
+          <p:cNvPr id="8" name="SectionBox2"/>
+          <p:cNvSpPr/>
+          <p:nvPr/>
+        </p:nvSpPr>
+        <p:spPr>
+          <a:xfrm>
+            <a:off x="4114560" y="1737360"/>
+            <a:ext cx="3657600" cy="457200"/>
+          </a:xfrm>
+          <a:prstGeom prst="rect">
+            <a:avLst/>
+          </a:prstGeom>
+          <a:solidFill>
+            <a:srgbClr val="D4AF37"/>
+          </a:solidFill>
+          <a:ln>
+            <a:noFill/>
+          </a:ln>
+        </p:spPr>
+        <p:txBody>
+          <a:bodyPr rtlCol="0" anchor="ctr"/>
+          <a:lstStyle/>
+          <a:p>
+            <a:pPr algn="ctr"/>
+          </a:p>
+        </p:txBody>
+      </p:sp>
+      <p:sp>
+        <p:nvSpPr>
+          <p:cNvPr id="9" name="SectionTitle2"/>
+          <p:cNvSpPr txBox="1"/>
+          <p:nvPr/>
+        </p:nvSpPr>
+        <p:spPr>
+          <a:xfrm>
+            <a:off x="4204560" y="1783080"/>
+            <a:ext cx="3483360" cy="365760"/>
+          </a:xfrm>
+          <a:prstGeom prst="rect">
+            <a:avLst/>
+          </a:prstGeom>
+          <a:noFill/>
+        </p:spPr>
+        <p:txBody>
+          <a:bodyPr wrap="square">
+            <a:spAutoFit/>
+          </a:bodyPr>
+          <a:lstStyle/>
+          <a:p>
+            <a:pPr algn="l"/>
+            <a:r>
+              <a:rPr sz="1400" b="1" i="0">
+                <a:solidFill>
+                  <a:srgbClr val="1A1A2E"/>
+                </a:solidFill>
+              </a:rPr>
+              <a:t>📊 情景分析总结</a:t>
+            </a:r>
+          </a:p>
+        </p:txBody>
+      </p:sp>
+      <p:graphicFrame>
+        <p:nvGraphicFramePr>
+          <p:cNvPr id="10" name="ScenarioTable"/>
+          <p:cNvGraphicFramePr>
+            <a:graphicFrameLocks noGrp="1"/>
+          </p:cNvGraphicFramePr>
+          <p:nvPr/>
+        </p:nvGraphicFramePr>
+        <p:xfrm>
+          <a:off x="4114560" y="2286000"/>
+          <a:ext cx="3657600" cy="2286000"/>
+        </p:xfrm>
+        <a:graphic>
+          <a:graphicData uri="http://schemas.openxmlformats.org/drawingml/2006/table">
+            <a:tbl>
+              <a:tblPr firstRow="1" bandRow="1">
+                <a:tableStyleId>{5C22544A-7EE6-4342-B048-85BDC9FD1C3A}</a:tableStyleId>
+              </a:tblPr>
+              <a:tblGrid>
+                <a:gridCol w="1000000"/>
+                <a:gridCol w="1300000"/>
+                <a:gridCol w="1357600"/>
+              </a:tblGrid>
+              <a:tr h="320000">
+                <a:tc>
+                  <a:txBody>
+                    <a:bodyPr/>
+                    <a:lstStyle/>
+                    <a:p>
+                      <a:pPr algn="ctr">
+                        <a:defRPr sz="1100" b="1">
+                          <a:solidFill>
+                            <a:srgbClr val="FFFFFF"/>
+                          </a:solidFill>
+                        </a:defRPr>
+                      </a:pPr>
+                      <a:r>
+                        <a:t>情景</a:t>
+                      </a:r>
+                    </a:p>
+                  </a:txBody>
+                  <a:tcPr>
+                    <a:solidFill>
+                      <a:srgbClr val="D4AF37"/>
+                    </a:solidFill>
+                  </a:tcPr>
+                </a:tc>
+                <a:tc>
+                  <a:txBody>
+                    <a:bodyPr/>
+                    <a:lstStyle/>
+                    <a:p>
+                      <a:pPr algn="ctr">
+                        <a:defRPr sz="1100" b="1">
+                          <a:solidFill>
+                            <a:srgbClr val="1A1A2E"/>
+                          </a:solidFill>
+                        </a:defRPr>
+                      </a:pPr>
+                      <a:r>
+                        <a:t>目标价</a:t>
+                      </a:r>
+                    </a:p>
+                  </a:txBody>
+                  <a:tcPr>
+                    <a:solidFill>
+                      <a:srgbClr val="D4AF37"/>
+                    </a:solidFill>
+                  </a:tcPr>
+                </a:tc>
+                <a:tc>
+                  <a:txBody>
+                    <a:bodyPr/>
+                    <a:lstStyle/>
+                    <a:p>
+                      <a:pPr algn="ctr">
+                        <a:defRPr sz="1100" b="1">
+                          <a:solidFill>
+                            <a:srgbClr val="1A1A2E"/>
+                          </a:solidFill>
+                        </a:defRPr>
+                      </a:pPr>
+                      <a:r>
+                        <a:t>潜在涨幅</a:t>
+                      </a:r>
+                    </a:p>
+                  </a:txBody>
+                  <a:tcPr>
+                    <a:solidFill>
+                      <a:srgbClr val="D4AF37"/>
+                    </a:solidFill>
+                  </a:tcPr>
+                </a:tc>
+              </a:tr>
+              <a:tr h="320000">
+                <a:tc>
+                  <a:txBody>
+                    <a:bodyPr/>
+                    <a:lstStyle/>
+                    <a:p>
+                      <a:pPr algn="ctr">
+                        <a:defRPr sz="1100" b="1">
+                          <a:solidFill>
+                            <a:srgbClr val="00FF00"/>
+                          </a:solidFill>
+                        </a:defRPr>
+                      </a:pPr>
+                      <a:r>
+                        <a:t>Bull</a:t>
+                      </a:r>
+                    </a:p>
+                  </a:txBody>
+                  <a:tcPr/>
+                </a:tc>
+                <a:tc>
+                  <a:txBody>
+                    <a:bodyPr/>
+                    <a:lstStyle/>
+                    <a:p>
+                      <a:pPr algn="ctr">
+                        <a:defRPr sz="1100" b="1">
+                          <a:solidFill>
+                            <a:srgbClr val="00FF00"/>
+                          </a:solidFill>
+                        </a:defRPr>
+                      </a:pPr>
+                      <a:r>
+                        <a:t>706港元</a:t>
+                      </a:r>
+                    </a:p>
+                  </a:txBody>
+                  <a:tcPr/>
+                </a:tc>
+                <a:tc>
+                  <a:txBody>
+                    <a:bodyPr/>
+                    <a:lstStyle/>
+                    <a:p>
+                      <a:pPr algn="ctr">
+                        <a:defRPr sz="1100" b="1">
+                          <a:solidFill>
+                            <a:srgbClr val="00FF00"/>
+                          </a:solidFill>
+                        </a:defRPr>
+                      </a:pPr>
+                      <a:r>
+                        <a:t>+61%</a:t>
+                      </a:r>
+                    </a:p>
+                  </a:txBody>
+                  <a:tcPr/>
+                </a:tc>
+              </a:tr>
+              <a:tr h="320000">
+                <a:tc>
+                  <a:txBody>
+                    <a:bodyPr/>
+                    <a:lstStyle/>
+                    <a:p>
+                      <a:pPr algn="ctr">
+                        <a:defRPr sz="1100" b="1">
+                          <a:solidFill>
+                            <a:srgbClr val="D4AF37"/>
+                          </a:solidFill>
+                        </a:defRPr>
+                      </a:pPr>
+                      <a:r>
+                        <a:t>Base</a:t>
+                      </a:r>
+                    </a:p>
+                  </a:txBody>
+                  <a:tcPr/>
+                </a:tc>
+                <a:tc>
+                  <a:txBody>
+                    <a:bodyPr/>
+                    <a:lstStyle/>
+                    <a:p>
+                      <a:pPr algn="ctr">
+                        <a:defRPr sz="1100" b="1">
+                          <a:solidFill>
+                            <a:srgbClr val="D4AF37"/>
+                          </a:solidFill>
+                        </a:defRPr>
+                      </a:pPr>
+                      <a:r>
+                        <a:t>545港元</a:t>
+                      </a:r>
+                    </a:p>
+                  </a:txBody>
+                  <a:tcPr/>
+                </a:tc>
+                <a:tc>
+                  <a:txBody>
+                    <a:bodyPr/>
+                    <a:lstStyle/>
+                    <a:p>
+                      <a:pPr algn="ctr">
+                        <a:defRPr sz="1100" b="1">
+                          <a:solidFill>
+                            <a:srgbClr val="D4AF37"/>
+                          </a:solidFill>
+                        </a:defRPr>
+                      </a:pPr>
+                      <a:r>
+                        <a:t>+24%</a:t>
+                      </a:r>
+                    </a:p>
+                  </a:txBody>
+                  <a:tcPr/>
+                </a:tc>
+              </a:tr>
+              <a:tr h="320000">
+                <a:tc>
+                  <a:txBody>
+                    <a:bodyPr/>
+                    <a:lstStyle/>
+                    <a:p>
+                      <a:pPr algn="ctr">
+                        <a:defRPr sz="1100" b="1">
+                          <a:solidFill>
+                            <a:srgbClr val="FF6666"/>
+                          </a:solidFill>
+                        </a:defRPr>
+                      </a:pPr>
+                      <a:r>
+                        <a:t>Bear</a:t>
+                      </a:r>
+                    </a:p>
+                  </a:txBody>
+                  <a:tcPr/>
+                </a:tc>
+                <a:tc>
+                  <a:txBody>
+                    <a:bodyPr/>
+                    <a:lstStyle/>
+                    <a:p>
+                      <a:pPr algn="ctr">
+                        <a:defRPr sz="1100" b="1">
+                          <a:solidFill>
+                            <a:srgbClr val="FF6666"/>
+                          </a:solidFill>
+                        </a:defRPr>
+                      </a:pPr>
+                      <a:r>
+                        <a:t>366港元</a:t>
+                      </a:r>
+                    </a:p>
+                  </a:txBody>
+                  <a:tcPr/>
+                </a:tc>
+                <a:tc>
+                  <a:txBody>
+                    <a:bodyPr/>
+                    <a:lstStyle/>
+                    <a:p>
+                      <a:pPr algn="ctr">
+                        <a:defRPr sz="1100" b="1">
+                          <a:solidFill>
+                            <a:srgbClr val="FF6666"/>
+                          </a:solidFill>
+                        </a:defRPr>
+                      </a:pPr>
+                      <a:r>
+                        <a:t>-17%</a:t>
+                      </a:r>
+                    </a:p>
+                  </a:txBody>
+                  <a:tcPr/>
+                </a:tc>
+              </a:tr>
+              <a:tr h="320000">
+                <a:tc>
+                  <a:txBody>
+                    <a:bodyPr/>
+                    <a:lstStyle/>
+                    <a:p>
+                      <a:pPr algn="l">
+                        <a:defRPr sz="1100">
+                          <a:solidFill>
+                            <a:srgbClr val="FFFFFF"/>
+                          </a:solidFill>
+                        </a:defRPr>
+                      </a:pPr>
+                      <a:r>
+                        <a:t>概率假设</a:t>
+                      </a:r>
+                    </a:p>
+                  </a:txBody>
+                  <a:tcPr/>
+                </a:tc>
+                <a:tc>
+                  <a:txBody>
+                    <a:bodyPr/>
+                    <a:lstStyle/>
+                    <a:p>
+                      <a:pPr algn="l">
+                        <a:defRPr sz="1100">
+                          <a:solidFill>
+                            <a:srgbClr val="FFFFFF"/>
+                          </a:solidFill>
+                        </a:defRPr>
+                      </a:pPr>
+                      <a:r>
+                        <a:t>各1/3基准</a:t>
+                      </a:r>
+                    </a:p>
+                  </a:txBody>
+                  <a:tcPr/>
+                </a:tc>
+                <a:tc>
+                  <a:txBody>
+                    <a:bodyPr/>
+                    <a:lstStyle/>
+                    <a:p>
+                      <a:pPr algn="l">
+                        <a:defRPr sz="1100">
+                          <a:solidFill>
+                            <a:srgbClr val="FFFFFF"/>
+                          </a:solidFill>
+                        </a:defRPr>
+                      </a:pPr>
+                      <a:r>
+                        <a:t>隐含期望值≈539</a:t>
+                      </a:r>
+                    </a:p>
+                  </a:txBody>
+                  <a:tcPr/>
+                </a:tc>
+              </a:tr>
+            </a:tbl>
+          </a:graphicData>
+        </a:graphic>
+      </p:graphicFrame>
+      <p:sp>
+        <p:nvSpPr>
+          <p:cNvPr id="11" name="SectionBox3"/>
+          <p:cNvSpPr/>
+          <p:nvPr/>
+        </p:nvSpPr>
+        <p:spPr>
+          <a:xfrm>
+            <a:off x="7942320" y="1737360"/>
+            <a:ext cx="4114560" cy="457200"/>
+          </a:xfrm>
+          <a:prstGeom prst="rect">
+            <a:avLst/>
+          </a:prstGeom>
+          <a:solidFill>
+            <a:srgbClr val="004A8A"/>
+          </a:solidFill>
+          <a:ln>
+            <a:noFill/>
+          </a:ln>
+        </p:spPr>
+        <p:txBody>
+          <a:bodyPr rtlCol="0" anchor="ctr"/>
+          <a:lstStyle/>
+          <a:p>
+            <a:pPr algn="ctr"/>
+          </a:p>
+        </p:txBody>
+      </p:sp>
+      <p:sp>
+        <p:nvSpPr>
+          <p:cNvPr id="12" name="SectionTitle3"/>
+          <p:cNvSpPr txBox="1"/>
+          <p:nvPr/>
+        </p:nvSpPr>
+        <p:spPr>
+          <a:xfrm>
+            <a:off x="8032320" y="1783080"/>
+            <a:ext cx="3940320" cy="365760"/>
+          </a:xfrm>
+          <a:prstGeom prst="rect">
+            <a:avLst/>
+          </a:prstGeom>
+          <a:noFill/>
+        </p:spPr>
+        <p:txBody>
+          <a:bodyPr wrap="square">
+            <a:spAutoFit/>
+          </a:bodyPr>
+          <a:lstStyle/>
+          <a:p>
+            <a:pPr algn="l"/>
+            <a:r>
+              <a:rPr sz="1400" b="1" i="0">
+                <a:solidFill>
+                  <a:srgbClr val="FFFFFF"/>
+                </a:solidFill>
+              </a:rPr>
+              <a:t>✅ 投资建议总结</a:t>
+            </a:r>
+          </a:p>
+        </p:txBody>
+      </p:sp>
+      <p:sp>
+        <p:nvSpPr>
+          <p:cNvPr id="13" name="AdviceBox"/>
+          <p:cNvSpPr txBox="1"/>
+          <p:nvPr/>
+        </p:nvSpPr>
+        <p:spPr>
+          <a:xfrm>
+            <a:off x="7942320" y="2286000"/>
+            <a:ext cx="4114560" cy="2286000"/>
+          </a:xfrm>
+          <a:prstGeom prst="rect">
+            <a:avLst/>
+          </a:prstGeom>
+          <a:solidFill>
+            <a:srgbClr val="002040"/>
+          </a:solidFill>
+          <a:ln>
+            <a:noFill/>
+          </a:ln>
+        </p:spPr>
+        <p:txBody>
+          <a:bodyPr wrap="square" rtlCol="0">
+            <a:spAutoFit/>
+          </a:bodyPr>
+          <a:lstStyle/>
+          <a:p>
+            <a:pPr algn="l"/>
+            <a:r>
+              <a:rPr sz="1200" b="1">
+                <a:solidFill>
+                  <a:srgbClr val="00FF00"/>
+                </a:solidFill>
+              </a:rPr>
+              <a:t>【中期】谨慎买入</a:t>
+            </a:r>
+          </a:p>
+          <a:p>
+            <a:pPr algn="l"/>
+            <a:r>
+              <a:rPr sz="1100">
+                <a:solidFill>
+                  <a:srgbClr val="FFFFFF"/>
+                </a:solidFill>
+              </a:rPr>
+              <a:t>• 当前PE 12倍低于历史中枢，安全边际充足</a:t>
+            </a:r>
+          </a:p>
+          <a:p>
+            <a:pPr algn="l"/>
+            <a:r>
+              <a:rPr sz="1100">
+                <a:solidFill>
+                  <a:srgbClr val="FFFFFF"/>
+                </a:solidFill>
+              </a:rPr>
+              <a:t>• 目标价470-520港元，Base情景+24%</a:t>
+            </a:r>
+          </a:p>
+          <a:p>
+            <a:pPr algn="l"/>
+            <a:r>
+              <a:rPr sz="1100">
+                <a:solidFill>
+                  <a:srgbClr val="FFFFFF"/>
+                </a:solidFill>
+              </a:rPr>
+              <a:t>• 等待催化剂确认（微信Agent/AI变现）</a:t>
+            </a:r>
+          </a:p>
+          <a:p>
+            <a:pPr algn="l"/>
+            <a:endParaRPr lang="en-US"/>
+          </a:p>
+          <a:p>
+            <a:pPr algn="l"/>
+            <a:r>
+              <a:rPr sz="1200" b="1">
+                <a:solidFill>
+                  <a:srgbClr val="00FF00"/>
+                </a:solidFill>
+              </a:rPr>
+              <a:t>【长期】强烈买入</a:t>
+            </a:r>
+          </a:p>
+          <a:p>
+            <a:pPr algn="l"/>
+            <a:r>
+              <a:rPr sz="1100">
+                <a:solidFill>
+                  <a:srgbClr val="FFFFFF"/>
+                </a:solidFill>
+              </a:rPr>
+              <a:t>• Agent生态一旦成型，护城河极难复制</a:t>
+            </a:r>
+          </a:p>
+          <a:p>
+            <a:pPr algn="l"/>
+            <a:r>
+              <a:rPr sz="1100">
+                <a:solidFill>
+                  <a:srgbClr val="FFFFFF"/>
+                </a:solidFill>
+              </a:rPr>
+              <a:t>• Bull情景706港元(+61%)，时间换空间</a:t>
+            </a:r>
+          </a:p>
+          <a:p>
+            <a:pPr algn="l"/>
+            <a:r>
+              <a:rPr sz="1100">
+                <a:solidFill>
+                  <a:srgbClr val="FFFFFF"/>
+                </a:solidFill>
+              </a:rPr>
+              <a:t>• 腾讯是中国AI应用端最强护城河</a:t>
+            </a:r>
+          </a:p>
+        </p:txBody>
+      </p:sp>
+      <p:sp>
+        <p:nvSpPr>
+          <p:cNvPr id="14" name="FooterBox"/>
+          <p:cNvSpPr/>
+          <p:nvPr/>
+        </p:nvSpPr>
+        <p:spPr>
+          <a:xfrm>
+            <a:off x="0" y="6400000"/>
+            <a:ext cx="12188952" cy="457600"/>
+          </a:xfrm>
+          <a:prstGeom prst="rect">
+            <a:avLst/>
+          </a:prstGeom>
+          <a:solidFill>
+            <a:srgbClr val="004A8A"/>
+          </a:solidFill>
+          <a:ln>
+            <a:noFill/>
+          </a:ln>
+        </p:spPr>
+        <p:txBody>
+          <a:bodyPr rtlCol="0" anchor="ctr"/>
+          <a:lstStyle/>
+          <a:p>
+            <a:pPr algn="ctr"/>
+            <a:r>
+              <a:rPr sz="1000">
+                <a:solidFill>
+                  <a:srgbClr val="AAAAAA"/>
+                </a:solidFill>
+              </a:rPr>
+              <a:t>数据来源：腾讯官方财报 / 分析师估算 | C Job Day 5 | CONFIDENTIAL</a:t>
+            </a:r>
+          </a:p>
+        </p:txBody>
+      </p:sp>
+    </p:spTree>
+  </p:cSld>
+  <p:clrMapOvr>
+    <a:masterClrMapping/>
+  </p:clrMapOvr>
 </p:sld>
 </file>
 

</xml_diff>